<commit_message>
Improve presentation with professional theme, typography, and visual hierarchy
</commit_message>
<xml_diff>
--- a/Academic Predictor Presentation.pptx
+++ b/Academic Predictor Presentation.pptx
@@ -3086,6 +3086,14 @@
 <file path=ppt/slides/slide1.xml><?xml version="1.0" encoding="utf-8"?>
 <p:sld xmlns:a="http://schemas.openxmlformats.org/drawingml/2006/main" xmlns:p="http://schemas.openxmlformats.org/presentationml/2006/main" xmlns:r="http://schemas.openxmlformats.org/officeDocument/2006/relationships">
   <p:cSld>
+    <p:bg>
+      <p:bgPr>
+        <a:solidFill>
+          <a:srgbClr val="19345F"/>
+        </a:solidFill>
+        <a:effectLst/>
+      </p:bgPr>
+    </p:bg>
     <p:spTree>
       <p:nvGrpSpPr>
         <p:cNvPr id="1" name=""/>
@@ -3095,35 +3103,14 @@
       <p:grpSpPr/>
       <p:sp>
         <p:nvSpPr>
-          <p:cNvPr id="2" name="Title 1"/>
-          <p:cNvSpPr>
-            <a:spLocks noGrp="1"/>
-          </p:cNvSpPr>
-          <p:nvPr>
-            <p:ph type="title"/>
-          </p:nvPr>
-        </p:nvSpPr>
-        <p:spPr/>
-        <p:txBody>
-          <a:bodyPr/>
-          <a:lstStyle/>
-          <a:p>
-            <a:r>
-              <a:t>The Multi-Subject Academic Predictor</a:t>
-            </a:r>
-          </a:p>
-        </p:txBody>
-      </p:sp>
-      <p:sp>
-        <p:nvSpPr>
-          <p:cNvPr id="3" name="TextBox 2"/>
+          <p:cNvPr id="2" name="TextBox 1"/>
           <p:cNvSpPr txBox="1"/>
           <p:nvPr/>
         </p:nvSpPr>
         <p:spPr>
           <a:xfrm>
-            <a:off x="914400" y="1371600"/>
-            <a:ext cx="7315200" cy="3657600"/>
+            <a:off x="457200" y="2286000"/>
+            <a:ext cx="8229600" cy="1371600"/>
           </a:xfrm>
           <a:prstGeom prst="rect">
             <a:avLst/>
@@ -3131,26 +3118,101 @@
           <a:noFill/>
         </p:spPr>
         <p:txBody>
-          <a:bodyPr wrap="none">
+          <a:bodyPr wrap="square">
             <a:spAutoFit/>
           </a:bodyPr>
           <a:lstStyle/>
           <a:p>
-            <a:pPr>
-              <a:defRPr sz="2400"/>
+            <a:pPr algn="ctr">
+              <a:defRPr sz="5400" b="1">
+                <a:solidFill>
+                  <a:srgbClr val="FFFFFF"/>
+                </a:solidFill>
+              </a:defRPr>
             </a:pPr>
             <a:r>
-              <a:t>Target student: Alex Anderson</a:t>
-            </a:r>
-          </a:p>
-          <a:p>
-            <a:r>
-              <a:t>Missing subject: Software Engineering</a:t>
-            </a:r>
-          </a:p>
-          <a:p>
-            <a:r>
-              <a:t>Objective: predict the missing final exam mark using existing subject scores.</a:t>
+              <a:t>The Multi-Subject</a:t>
+            </a:r>
+            <a:br/>
+            <a:r>
+              <a:t>Academic Predictor</a:t>
+            </a:r>
+          </a:p>
+        </p:txBody>
+      </p:sp>
+      <p:sp>
+        <p:nvSpPr>
+          <p:cNvPr id="3" name="TextBox 2"/>
+          <p:cNvSpPr txBox="1"/>
+          <p:nvPr/>
+        </p:nvSpPr>
+        <p:spPr>
+          <a:xfrm>
+            <a:off x="457200" y="3840480"/>
+            <a:ext cx="8229600" cy="2286000"/>
+          </a:xfrm>
+          <a:prstGeom prst="rect">
+            <a:avLst/>
+          </a:prstGeom>
+          <a:noFill/>
+        </p:spPr>
+        <p:txBody>
+          <a:bodyPr wrap="square">
+            <a:spAutoFit/>
+          </a:bodyPr>
+          <a:lstStyle/>
+          <a:p>
+            <a:pPr algn="ctr">
+              <a:spcBef>
+                <a:spcPts val="600"/>
+              </a:spcBef>
+              <a:spcAft>
+                <a:spcPts val="600"/>
+              </a:spcAft>
+              <a:defRPr sz="2400">
+                <a:solidFill>
+                  <a:srgbClr val="F0F0F0"/>
+                </a:solidFill>
+              </a:defRPr>
+            </a:pPr>
+            <a:r>
+              <a:t>Target Student: Alex Anderson</a:t>
+            </a:r>
+          </a:p>
+          <a:p>
+            <a:pPr algn="ctr">
+              <a:spcBef>
+                <a:spcPts val="600"/>
+              </a:spcBef>
+              <a:spcAft>
+                <a:spcPts val="600"/>
+              </a:spcAft>
+              <a:defRPr sz="2400">
+                <a:solidFill>
+                  <a:srgbClr val="F0F0F0"/>
+                </a:solidFill>
+              </a:defRPr>
+            </a:pPr>
+            <a:r>
+              <a:t>Missing Subject: Software Engineering</a:t>
+            </a:r>
+          </a:p>
+          <a:p>
+            <a:pPr algn="ctr">
+              <a:spcBef>
+                <a:spcPts val="600"/>
+              </a:spcBef>
+              <a:spcAft>
+                <a:spcPts val="600"/>
+              </a:spcAft>
+              <a:defRPr sz="2400">
+                <a:solidFill>
+                  <a:srgbClr val="F0F0F0"/>
+                </a:solidFill>
+              </a:defRPr>
+            </a:pPr>
+            <a:r>
+              <a:t>HSC Software Engineering (Stage 6)</a:t>
             </a:r>
           </a:p>
         </p:txBody>
@@ -3166,6 +3228,14 @@
 <file path=ppt/slides/slide2.xml><?xml version="1.0" encoding="utf-8"?>
 <p:sld xmlns:a="http://schemas.openxmlformats.org/drawingml/2006/main" xmlns:p="http://schemas.openxmlformats.org/presentationml/2006/main" xmlns:r="http://schemas.openxmlformats.org/officeDocument/2006/relationships">
   <p:cSld>
+    <p:bg>
+      <p:bgPr>
+        <a:solidFill>
+          <a:srgbClr val="FFFFFF"/>
+        </a:solidFill>
+        <a:effectLst/>
+      </p:bgPr>
+    </p:bg>
     <p:spTree>
       <p:nvGrpSpPr>
         <p:cNvPr id="1" name=""/>
@@ -3175,19 +3245,47 @@
       <p:grpSpPr/>
       <p:sp>
         <p:nvSpPr>
-          <p:cNvPr id="2" name="Title 1"/>
-          <p:cNvSpPr>
-            <a:spLocks noGrp="1"/>
-          </p:cNvSpPr>
-          <p:nvPr>
-            <p:ph type="title"/>
-          </p:nvPr>
-        </p:nvSpPr>
-        <p:spPr/>
-        <p:txBody>
-          <a:bodyPr/>
-          <a:lstStyle/>
-          <a:p/>
+          <p:cNvPr id="2" name="Rectangle 1"/>
+          <p:cNvSpPr/>
+          <p:nvPr/>
+        </p:nvSpPr>
+        <p:spPr>
+          <a:xfrm>
+            <a:off x="0" y="0"/>
+            <a:ext cx="9144000" cy="914400"/>
+          </a:xfrm>
+          <a:prstGeom prst="rect">
+            <a:avLst/>
+          </a:prstGeom>
+          <a:solidFill>
+            <a:srgbClr val="19345F"/>
+          </a:solidFill>
+          <a:ln>
+            <a:solidFill>
+              <a:srgbClr val="19345F"/>
+            </a:solidFill>
+          </a:ln>
+        </p:spPr>
+        <p:style>
+          <a:lnRef idx="1">
+            <a:schemeClr val="accent1"/>
+          </a:lnRef>
+          <a:fillRef idx="3">
+            <a:schemeClr val="accent1"/>
+          </a:fillRef>
+          <a:effectRef idx="2">
+            <a:schemeClr val="accent1"/>
+          </a:effectRef>
+          <a:fontRef idx="minor">
+            <a:schemeClr val="lt1"/>
+          </a:fontRef>
+        </p:style>
+        <p:txBody>
+          <a:bodyPr rtlCol="0" anchor="ctr"/>
+          <a:lstStyle/>
+          <a:p>
+            <a:pPr algn="ctr"/>
+          </a:p>
         </p:txBody>
       </p:sp>
       <p:sp>
@@ -3198,8 +3296,8 @@
         </p:nvSpPr>
         <p:spPr>
           <a:xfrm>
-            <a:off x="457200" y="457200"/>
-            <a:ext cx="8229600" cy="1143000"/>
+            <a:off x="457200" y="137160"/>
+            <a:ext cx="8229600" cy="640080"/>
           </a:xfrm>
           <a:prstGeom prst="rect">
             <a:avLst/>
@@ -3213,7 +3311,11 @@
           <a:lstStyle/>
           <a:p>
             <a:pPr>
-              <a:defRPr sz="3200"/>
+              <a:defRPr sz="4000" b="1">
+                <a:solidFill>
+                  <a:srgbClr val="FFFFFF"/>
+                </a:solidFill>
+              </a:defRPr>
             </a:pPr>
             <a:r>
               <a:t>Mathematical Justification</a:t>
@@ -3229,8 +3331,8 @@
         </p:nvSpPr>
         <p:spPr>
           <a:xfrm>
-            <a:off x="457200" y="1600200"/>
-            <a:ext cx="8229600" cy="3657600"/>
+            <a:off x="685800" y="1188720"/>
+            <a:ext cx="7772400" cy="5303520"/>
           </a:xfrm>
           <a:prstGeom prst="rect">
             <a:avLst/>
@@ -3238,26 +3340,113 @@
           <a:noFill/>
         </p:spPr>
         <p:txBody>
-          <a:bodyPr wrap="none">
+          <a:bodyPr wrap="square">
             <a:spAutoFit/>
           </a:bodyPr>
           <a:lstStyle/>
           <a:p>
             <a:pPr>
-              <a:defRPr sz="2000"/>
+              <a:lnSpc>
+                <a:spcPct val="115000"/>
+              </a:lnSpc>
+              <a:spcBef>
+                <a:spcPts val="800"/>
+              </a:spcBef>
+              <a:spcAft>
+                <a:spcPts val="800"/>
+              </a:spcAft>
+              <a:defRPr sz="1800">
+                <a:solidFill>
+                  <a:srgbClr val="282828"/>
+                </a:solidFill>
+              </a:defRPr>
             </a:pPr>
             <a:r>
-              <a:t>● Model: Linear regression with feature scaling (StandardScaler)</a:t>
-            </a:r>
-          </a:p>
-          <a:p>
-            <a:r>
-              <a:t>● Libraries: pandas, numpy, scikit-learn, python-pptx</a:t>
-            </a:r>
-          </a:p>
-          <a:p>
-            <a:r>
-              <a:t>● Justification: ML uses correlations among Maths, Physics, and Modern History to make a more rigorous prediction than a simple average.</a:t>
+              <a:t>● Algorithm: Linear Regression with StandardScaler</a:t>
+            </a:r>
+          </a:p>
+          <a:p>
+            <a:pPr>
+              <a:lnSpc>
+                <a:spcPct val="115000"/>
+              </a:lnSpc>
+              <a:spcBef>
+                <a:spcPts val="800"/>
+              </a:spcBef>
+              <a:spcAft>
+                <a:spcPts val="800"/>
+              </a:spcAft>
+              <a:defRPr sz="1800">
+                <a:solidFill>
+                  <a:srgbClr val="282828"/>
+                </a:solidFill>
+              </a:defRPr>
+            </a:pPr>
+            <a:r>
+              <a:t>● Features: Maths Advanced, Physics, Modern History</a:t>
+            </a:r>
+          </a:p>
+          <a:p>
+            <a:pPr>
+              <a:lnSpc>
+                <a:spcPct val="115000"/>
+              </a:lnSpc>
+              <a:spcBef>
+                <a:spcPts val="800"/>
+              </a:spcBef>
+              <a:spcAft>
+                <a:spcPts val="800"/>
+              </a:spcAft>
+              <a:defRPr sz="1800">
+                <a:solidFill>
+                  <a:srgbClr val="282828"/>
+                </a:solidFill>
+              </a:defRPr>
+            </a:pPr>
+            <a:r>
+              <a:t>● Why ML? Captures subject correlations for fairer prediction than flat averaging</a:t>
+            </a:r>
+          </a:p>
+          <a:p>
+            <a:pPr>
+              <a:lnSpc>
+                <a:spcPct val="115000"/>
+              </a:lnSpc>
+              <a:spcBef>
+                <a:spcPts val="800"/>
+              </a:spcBef>
+              <a:spcAft>
+                <a:spcPts val="800"/>
+              </a:spcAft>
+              <a:defRPr sz="1800">
+                <a:solidFill>
+                  <a:srgbClr val="282828"/>
+                </a:solidFill>
+              </a:defRPr>
+            </a:pPr>
+            <a:r>
+              <a:t>● Libraries: pandas, numpy, scikit-learn, python-docx, python-pptx</a:t>
+            </a:r>
+          </a:p>
+          <a:p>
+            <a:pPr>
+              <a:lnSpc>
+                <a:spcPct val="115000"/>
+              </a:lnSpc>
+              <a:spcBef>
+                <a:spcPts val="800"/>
+              </a:spcBef>
+              <a:spcAft>
+                <a:spcPts val="800"/>
+              </a:spcAft>
+              <a:defRPr sz="1800">
+                <a:solidFill>
+                  <a:srgbClr val="282828"/>
+                </a:solidFill>
+              </a:defRPr>
+            </a:pPr>
+            <a:r>
+              <a:t>● Benefit: Mathematically rigorous and objective grade estimation</a:t>
             </a:r>
           </a:p>
         </p:txBody>
@@ -3273,6 +3462,14 @@
 <file path=ppt/slides/slide3.xml><?xml version="1.0" encoding="utf-8"?>
 <p:sld xmlns:a="http://schemas.openxmlformats.org/drawingml/2006/main" xmlns:p="http://schemas.openxmlformats.org/presentationml/2006/main" xmlns:r="http://schemas.openxmlformats.org/officeDocument/2006/relationships">
   <p:cSld>
+    <p:bg>
+      <p:bgPr>
+        <a:solidFill>
+          <a:srgbClr val="FFFFFF"/>
+        </a:solidFill>
+        <a:effectLst/>
+      </p:bgPr>
+    </p:bg>
     <p:spTree>
       <p:nvGrpSpPr>
         <p:cNvPr id="1" name=""/>
@@ -3282,19 +3479,47 @@
       <p:grpSpPr/>
       <p:sp>
         <p:nvSpPr>
-          <p:cNvPr id="2" name="Title 1"/>
-          <p:cNvSpPr>
-            <a:spLocks noGrp="1"/>
-          </p:cNvSpPr>
-          <p:nvPr>
-            <p:ph type="title"/>
-          </p:nvPr>
-        </p:nvSpPr>
-        <p:spPr/>
-        <p:txBody>
-          <a:bodyPr/>
-          <a:lstStyle/>
-          <a:p/>
+          <p:cNvPr id="2" name="Rectangle 1"/>
+          <p:cNvSpPr/>
+          <p:nvPr/>
+        </p:nvSpPr>
+        <p:spPr>
+          <a:xfrm>
+            <a:off x="0" y="0"/>
+            <a:ext cx="9144000" cy="914400"/>
+          </a:xfrm>
+          <a:prstGeom prst="rect">
+            <a:avLst/>
+          </a:prstGeom>
+          <a:solidFill>
+            <a:srgbClr val="19345F"/>
+          </a:solidFill>
+          <a:ln>
+            <a:solidFill>
+              <a:srgbClr val="19345F"/>
+            </a:solidFill>
+          </a:ln>
+        </p:spPr>
+        <p:style>
+          <a:lnRef idx="1">
+            <a:schemeClr val="accent1"/>
+          </a:lnRef>
+          <a:fillRef idx="3">
+            <a:schemeClr val="accent1"/>
+          </a:fillRef>
+          <a:effectRef idx="2">
+            <a:schemeClr val="accent1"/>
+          </a:effectRef>
+          <a:fontRef idx="minor">
+            <a:schemeClr val="lt1"/>
+          </a:fontRef>
+        </p:style>
+        <p:txBody>
+          <a:bodyPr rtlCol="0" anchor="ctr"/>
+          <a:lstStyle/>
+          <a:p>
+            <a:pPr algn="ctr"/>
+          </a:p>
         </p:txBody>
       </p:sp>
       <p:sp>
@@ -3305,8 +3530,8 @@
         </p:nvSpPr>
         <p:spPr>
           <a:xfrm>
-            <a:off x="457200" y="457200"/>
-            <a:ext cx="8229600" cy="1143000"/>
+            <a:off x="457200" y="137160"/>
+            <a:ext cx="8229600" cy="640080"/>
           </a:xfrm>
           <a:prstGeom prst="rect">
             <a:avLst/>
@@ -3320,7 +3545,11 @@
           <a:lstStyle/>
           <a:p>
             <a:pPr>
-              <a:defRPr sz="3200"/>
+              <a:defRPr sz="4000" b="1">
+                <a:solidFill>
+                  <a:srgbClr val="FFFFFF"/>
+                </a:solidFill>
+              </a:defRPr>
             </a:pPr>
             <a:r>
               <a:t>Visual Proof of Accuracy</a:t>
@@ -3336,8 +3565,8 @@
         </p:nvSpPr>
         <p:spPr>
           <a:xfrm>
-            <a:off x="457200" y="1600200"/>
-            <a:ext cx="8229600" cy="3657600"/>
+            <a:off x="685800" y="1188720"/>
+            <a:ext cx="7772400" cy="5303520"/>
           </a:xfrm>
           <a:prstGeom prst="rect">
             <a:avLst/>
@@ -3345,31 +3574,113 @@
           <a:noFill/>
         </p:spPr>
         <p:txBody>
-          <a:bodyPr wrap="none">
+          <a:bodyPr wrap="square">
             <a:spAutoFit/>
           </a:bodyPr>
           <a:lstStyle/>
           <a:p>
             <a:pPr>
-              <a:defRPr sz="2000"/>
+              <a:lnSpc>
+                <a:spcPct val="115000"/>
+              </a:lnSpc>
+              <a:spcBef>
+                <a:spcPts val="800"/>
+              </a:spcBef>
+              <a:spcAft>
+                <a:spcPts val="800"/>
+              </a:spcAft>
+              <a:defRPr sz="1800">
+                <a:solidFill>
+                  <a:srgbClr val="282828"/>
+                </a:solidFill>
+              </a:defRPr>
             </a:pPr>
             <a:r>
-              <a:t>● Final RMSE on test set: 4.96</a:t>
-            </a:r>
-          </a:p>
-          <a:p>
-            <a:r>
-              <a:t>● 5-fold cross-validation RMSE: 3.45</a:t>
-            </a:r>
-          </a:p>
-          <a:p>
-            <a:r>
-              <a:t>● Prediction for Alex Anderson: 85.8</a:t>
-            </a:r>
-          </a:p>
-          <a:p>
-            <a:r>
-              <a:t>● Interpretation: Expected error ~±5 marks, which is acceptable for this predictive assessment.</a:t>
+              <a:t>● Test Set RMSE: 4.96 marks</a:t>
+            </a:r>
+          </a:p>
+          <a:p>
+            <a:pPr>
+              <a:lnSpc>
+                <a:spcPct val="115000"/>
+              </a:lnSpc>
+              <a:spcBef>
+                <a:spcPts val="800"/>
+              </a:spcBef>
+              <a:spcAft>
+                <a:spcPts val="800"/>
+              </a:spcAft>
+              <a:defRPr sz="1800">
+                <a:solidFill>
+                  <a:srgbClr val="282828"/>
+                </a:solidFill>
+              </a:defRPr>
+            </a:pPr>
+            <a:r>
+              <a:t>● 5-Fold Cross-Validation RMSE: 3.45 marks</a:t>
+            </a:r>
+          </a:p>
+          <a:p>
+            <a:pPr>
+              <a:lnSpc>
+                <a:spcPct val="115000"/>
+              </a:lnSpc>
+              <a:spcBef>
+                <a:spcPts val="800"/>
+              </a:spcBef>
+              <a:spcAft>
+                <a:spcPts val="800"/>
+              </a:spcAft>
+              <a:defRPr sz="1800">
+                <a:solidFill>
+                  <a:srgbClr val="282828"/>
+                </a:solidFill>
+              </a:defRPr>
+            </a:pPr>
+            <a:r>
+              <a:t>● Predicted Score (Alex): 85.8 / 100</a:t>
+            </a:r>
+          </a:p>
+          <a:p>
+            <a:pPr>
+              <a:lnSpc>
+                <a:spcPct val="115000"/>
+              </a:lnSpc>
+              <a:spcBef>
+                <a:spcPts val="800"/>
+              </a:spcBef>
+              <a:spcAft>
+                <a:spcPts val="800"/>
+              </a:spcAft>
+              <a:defRPr sz="1800">
+                <a:solidFill>
+                  <a:srgbClr val="282828"/>
+                </a:solidFill>
+              </a:defRPr>
+            </a:pPr>
+            <a:r>
+              <a:t>● Expected Error Margin: ±5.0 marks</a:t>
+            </a:r>
+          </a:p>
+          <a:p>
+            <a:pPr>
+              <a:lnSpc>
+                <a:spcPct val="115000"/>
+              </a:lnSpc>
+              <a:spcBef>
+                <a:spcPts val="800"/>
+              </a:spcBef>
+              <a:spcAft>
+                <a:spcPts val="800"/>
+              </a:spcAft>
+              <a:defRPr sz="1800">
+                <a:solidFill>
+                  <a:srgbClr val="282828"/>
+                </a:solidFill>
+              </a:defRPr>
+            </a:pPr>
+            <a:r>
+              <a:t>● Assessment: Error margin is acceptable for formative grade prediction</a:t>
             </a:r>
           </a:p>
         </p:txBody>
@@ -3385,6 +3696,14 @@
 <file path=ppt/slides/slide4.xml><?xml version="1.0" encoding="utf-8"?>
 <p:sld xmlns:a="http://schemas.openxmlformats.org/drawingml/2006/main" xmlns:p="http://schemas.openxmlformats.org/presentationml/2006/main" xmlns:r="http://schemas.openxmlformats.org/officeDocument/2006/relationships">
   <p:cSld>
+    <p:bg>
+      <p:bgPr>
+        <a:solidFill>
+          <a:srgbClr val="FFFFFF"/>
+        </a:solidFill>
+        <a:effectLst/>
+      </p:bgPr>
+    </p:bg>
     <p:spTree>
       <p:nvGrpSpPr>
         <p:cNvPr id="1" name=""/>
@@ -3394,19 +3713,47 @@
       <p:grpSpPr/>
       <p:sp>
         <p:nvSpPr>
-          <p:cNvPr id="2" name="Title 1"/>
-          <p:cNvSpPr>
-            <a:spLocks noGrp="1"/>
-          </p:cNvSpPr>
-          <p:nvPr>
-            <p:ph type="title"/>
-          </p:nvPr>
-        </p:nvSpPr>
-        <p:spPr/>
-        <p:txBody>
-          <a:bodyPr/>
-          <a:lstStyle/>
-          <a:p/>
+          <p:cNvPr id="2" name="Rectangle 1"/>
+          <p:cNvSpPr/>
+          <p:nvPr/>
+        </p:nvSpPr>
+        <p:spPr>
+          <a:xfrm>
+            <a:off x="0" y="0"/>
+            <a:ext cx="9144000" cy="914400"/>
+          </a:xfrm>
+          <a:prstGeom prst="rect">
+            <a:avLst/>
+          </a:prstGeom>
+          <a:solidFill>
+            <a:srgbClr val="19345F"/>
+          </a:solidFill>
+          <a:ln>
+            <a:solidFill>
+              <a:srgbClr val="19345F"/>
+            </a:solidFill>
+          </a:ln>
+        </p:spPr>
+        <p:style>
+          <a:lnRef idx="1">
+            <a:schemeClr val="accent1"/>
+          </a:lnRef>
+          <a:fillRef idx="3">
+            <a:schemeClr val="accent1"/>
+          </a:fillRef>
+          <a:effectRef idx="2">
+            <a:schemeClr val="accent1"/>
+          </a:effectRef>
+          <a:fontRef idx="minor">
+            <a:schemeClr val="lt1"/>
+          </a:fontRef>
+        </p:style>
+        <p:txBody>
+          <a:bodyPr rtlCol="0" anchor="ctr"/>
+          <a:lstStyle/>
+          <a:p>
+            <a:pPr algn="ctr"/>
+          </a:p>
         </p:txBody>
       </p:sp>
       <p:sp>
@@ -3417,8 +3764,8 @@
         </p:nvSpPr>
         <p:spPr>
           <a:xfrm>
-            <a:off x="457200" y="457200"/>
-            <a:ext cx="8229600" cy="1143000"/>
+            <a:off x="457200" y="137160"/>
+            <a:ext cx="8229600" cy="640080"/>
           </a:xfrm>
           <a:prstGeom prst="rect">
             <a:avLst/>
@@ -3432,7 +3779,11 @@
           <a:lstStyle/>
           <a:p>
             <a:pPr>
-              <a:defRPr sz="3200"/>
+              <a:defRPr sz="4000" b="1">
+                <a:solidFill>
+                  <a:srgbClr val="FFFFFF"/>
+                </a:solidFill>
+              </a:defRPr>
             </a:pPr>
             <a:r>
               <a:t>System Architecture (OOP)</a:t>
@@ -3448,8 +3799,8 @@
         </p:nvSpPr>
         <p:spPr>
           <a:xfrm>
-            <a:off x="457200" y="1600200"/>
-            <a:ext cx="8229600" cy="3657600"/>
+            <a:off x="685800" y="1188720"/>
+            <a:ext cx="7772400" cy="5303520"/>
           </a:xfrm>
           <a:prstGeom prst="rect">
             <a:avLst/>
@@ -3457,26 +3808,113 @@
           <a:noFill/>
         </p:spPr>
         <p:txBody>
-          <a:bodyPr wrap="none">
+          <a:bodyPr wrap="square">
             <a:spAutoFit/>
           </a:bodyPr>
           <a:lstStyle/>
           <a:p>
             <a:pPr>
-              <a:defRPr sz="2000"/>
+              <a:lnSpc>
+                <a:spcPct val="115000"/>
+              </a:lnSpc>
+              <a:spcBef>
+                <a:spcPts val="800"/>
+              </a:spcBef>
+              <a:spcAft>
+                <a:spcPts val="800"/>
+              </a:spcAft>
+              <a:defRPr sz="1800">
+                <a:solidFill>
+                  <a:srgbClr val="282828"/>
+                </a:solidFill>
+              </a:defRPr>
             </a:pPr>
             <a:r>
-              <a:t>● AcademicPredictor class handles data loading, cleaning, training, evaluating, and predicting.</a:t>
-            </a:r>
-          </a:p>
-          <a:p>
-            <a:r>
-              <a:t>● OOP gives modular, reusable structure and avoids global variables.</a:t>
-            </a:r>
-          </a:p>
-          <a:p>
-            <a:r>
-              <a:t>● Encapsulation supports future subject extensions and easier debugging.</a:t>
+              <a:t>● AcademicPredictor class: encapsulates data pipeline</a:t>
+            </a:r>
+          </a:p>
+          <a:p>
+            <a:pPr>
+              <a:lnSpc>
+                <a:spcPct val="115000"/>
+              </a:lnSpc>
+              <a:spcBef>
+                <a:spcPts val="800"/>
+              </a:spcBef>
+              <a:spcAft>
+                <a:spcPts val="800"/>
+              </a:spcAft>
+              <a:defRPr sz="1800">
+                <a:solidFill>
+                  <a:srgbClr val="282828"/>
+                </a:solidFill>
+              </a:defRPr>
+            </a:pPr>
+            <a:r>
+              <a:t>● Methods: load_data(), clean_data(), train(), evaluate_rmse(), predict_student()</a:t>
+            </a:r>
+          </a:p>
+          <a:p>
+            <a:pPr>
+              <a:lnSpc>
+                <a:spcPct val="115000"/>
+              </a:lnSpc>
+              <a:spcBef>
+                <a:spcPts val="800"/>
+              </a:spcBef>
+              <a:spcAft>
+                <a:spcPts val="800"/>
+              </a:spcAft>
+              <a:defRPr sz="1800">
+                <a:solidFill>
+                  <a:srgbClr val="282828"/>
+                </a:solidFill>
+              </a:defRPr>
+            </a:pPr>
+            <a:r>
+              <a:t>● Benefits: modularity, reusability, maintainability, security</a:t>
+            </a:r>
+          </a:p>
+          <a:p>
+            <a:pPr>
+              <a:lnSpc>
+                <a:spcPct val="115000"/>
+              </a:lnSpc>
+              <a:spcBef>
+                <a:spcPts val="800"/>
+              </a:spcBef>
+              <a:spcAft>
+                <a:spcPts val="800"/>
+              </a:spcAft>
+              <a:defRPr sz="1800">
+                <a:solidFill>
+                  <a:srgbClr val="282828"/>
+                </a:solidFill>
+              </a:defRPr>
+            </a:pPr>
+            <a:r>
+              <a:t>● Design: separates concerns, avoids global state</a:t>
+            </a:r>
+          </a:p>
+          <a:p>
+            <a:pPr>
+              <a:lnSpc>
+                <a:spcPct val="115000"/>
+              </a:lnSpc>
+              <a:spcBef>
+                <a:spcPts val="800"/>
+              </a:spcBef>
+              <a:spcAft>
+                <a:spcPts val="800"/>
+              </a:spcAft>
+              <a:defRPr sz="1800">
+                <a:solidFill>
+                  <a:srgbClr val="282828"/>
+                </a:solidFill>
+              </a:defRPr>
+            </a:pPr>
+            <a:r>
+              <a:t>● Future-proof: easily adapted for other subjects or predictors</a:t>
             </a:r>
           </a:p>
         </p:txBody>
@@ -3492,6 +3930,14 @@
 <file path=ppt/slides/slide5.xml><?xml version="1.0" encoding="utf-8"?>
 <p:sld xmlns:a="http://schemas.openxmlformats.org/drawingml/2006/main" xmlns:p="http://schemas.openxmlformats.org/presentationml/2006/main" xmlns:r="http://schemas.openxmlformats.org/officeDocument/2006/relationships">
   <p:cSld>
+    <p:bg>
+      <p:bgPr>
+        <a:solidFill>
+          <a:srgbClr val="FFFFFF"/>
+        </a:solidFill>
+        <a:effectLst/>
+      </p:bgPr>
+    </p:bg>
     <p:spTree>
       <p:nvGrpSpPr>
         <p:cNvPr id="1" name=""/>
@@ -3501,19 +3947,47 @@
       <p:grpSpPr/>
       <p:sp>
         <p:nvSpPr>
-          <p:cNvPr id="2" name="Title 1"/>
-          <p:cNvSpPr>
-            <a:spLocks noGrp="1"/>
-          </p:cNvSpPr>
-          <p:nvPr>
-            <p:ph type="title"/>
-          </p:nvPr>
-        </p:nvSpPr>
-        <p:spPr/>
-        <p:txBody>
-          <a:bodyPr/>
-          <a:lstStyle/>
-          <a:p/>
+          <p:cNvPr id="2" name="Rectangle 1"/>
+          <p:cNvSpPr/>
+          <p:nvPr/>
+        </p:nvSpPr>
+        <p:spPr>
+          <a:xfrm>
+            <a:off x="0" y="0"/>
+            <a:ext cx="9144000" cy="914400"/>
+          </a:xfrm>
+          <a:prstGeom prst="rect">
+            <a:avLst/>
+          </a:prstGeom>
+          <a:solidFill>
+            <a:srgbClr val="19345F"/>
+          </a:solidFill>
+          <a:ln>
+            <a:solidFill>
+              <a:srgbClr val="19345F"/>
+            </a:solidFill>
+          </a:ln>
+        </p:spPr>
+        <p:style>
+          <a:lnRef idx="1">
+            <a:schemeClr val="accent1"/>
+          </a:lnRef>
+          <a:fillRef idx="3">
+            <a:schemeClr val="accent1"/>
+          </a:fillRef>
+          <a:effectRef idx="2">
+            <a:schemeClr val="accent1"/>
+          </a:effectRef>
+          <a:fontRef idx="minor">
+            <a:schemeClr val="lt1"/>
+          </a:fontRef>
+        </p:style>
+        <p:txBody>
+          <a:bodyPr rtlCol="0" anchor="ctr"/>
+          <a:lstStyle/>
+          <a:p>
+            <a:pPr algn="ctr"/>
+          </a:p>
         </p:txBody>
       </p:sp>
       <p:sp>
@@ -3524,8 +3998,8 @@
         </p:nvSpPr>
         <p:spPr>
           <a:xfrm>
-            <a:off x="457200" y="457200"/>
-            <a:ext cx="8229600" cy="1143000"/>
+            <a:off x="457200" y="137160"/>
+            <a:ext cx="8229600" cy="640080"/>
           </a:xfrm>
           <a:prstGeom prst="rect">
             <a:avLst/>
@@ -3539,7 +4013,11 @@
           <a:lstStyle/>
           <a:p>
             <a:pPr>
-              <a:defRPr sz="3200"/>
+              <a:defRPr sz="4000" b="1">
+                <a:solidFill>
+                  <a:srgbClr val="FFFFFF"/>
+                </a:solidFill>
+              </a:defRPr>
             </a:pPr>
             <a:r>
               <a:t>Ethical Safeguards &amp; Bias Audit</a:t>
@@ -3555,8 +4033,8 @@
         </p:nvSpPr>
         <p:spPr>
           <a:xfrm>
-            <a:off x="457200" y="1600200"/>
-            <a:ext cx="8229600" cy="3657600"/>
+            <a:off x="685800" y="1188720"/>
+            <a:ext cx="7772400" cy="5303520"/>
           </a:xfrm>
           <a:prstGeom prst="rect">
             <a:avLst/>
@@ -3564,26 +4042,113 @@
           <a:noFill/>
         </p:spPr>
         <p:txBody>
-          <a:bodyPr wrap="none">
+          <a:bodyPr wrap="square">
             <a:spAutoFit/>
           </a:bodyPr>
           <a:lstStyle/>
           <a:p>
             <a:pPr>
-              <a:defRPr sz="2000"/>
+              <a:lnSpc>
+                <a:spcPct val="115000"/>
+              </a:lnSpc>
+              <a:spcBef>
+                <a:spcPts val="800"/>
+              </a:spcBef>
+              <a:spcAft>
+                <a:spcPts val="800"/>
+              </a:spcAft>
+              <a:defRPr sz="1800">
+                <a:solidFill>
+                  <a:srgbClr val="282828"/>
+                </a:solidFill>
+              </a:defRPr>
             </a:pPr>
             <a:r>
-              <a:t>● Privacy: Student_Name is anonymized to Student_ID and excluded from training.</a:t>
-            </a:r>
-          </a:p>
-          <a:p>
-            <a:r>
-              <a:t>● Bias Audit: Compared performance groups for Physics and Modern History.</a:t>
-            </a:r>
-          </a:p>
-          <a:p>
-            <a:r>
-              <a:t>● Result: No strong disparate impact was observed in the available dataset.</a:t>
+              <a:t>● Privacy: Student names anonymized to hashed IDs</a:t>
+            </a:r>
+          </a:p>
+          <a:p>
+            <a:pPr>
+              <a:lnSpc>
+                <a:spcPct val="115000"/>
+              </a:lnSpc>
+              <a:spcBef>
+                <a:spcPts val="800"/>
+              </a:spcBef>
+              <a:spcAft>
+                <a:spcPts val="800"/>
+              </a:spcAft>
+              <a:defRPr sz="1800">
+                <a:solidFill>
+                  <a:srgbClr val="282828"/>
+                </a:solidFill>
+              </a:defRPr>
+            </a:pPr>
+            <a:r>
+              <a:t>● Data Security: raw data never overwritten, cleaned data separated</a:t>
+            </a:r>
+          </a:p>
+          <a:p>
+            <a:pPr>
+              <a:lnSpc>
+                <a:spcPct val="115000"/>
+              </a:lnSpc>
+              <a:spcBef>
+                <a:spcPts val="800"/>
+              </a:spcBef>
+              <a:spcAft>
+                <a:spcPts val="800"/>
+              </a:spcAft>
+              <a:defRPr sz="1800">
+                <a:solidFill>
+                  <a:srgbClr val="282828"/>
+                </a:solidFill>
+              </a:defRPr>
+            </a:pPr>
+            <a:r>
+              <a:t>● Bias Audit: compared error rates across subject-performance groups</a:t>
+            </a:r>
+          </a:p>
+          <a:p>
+            <a:pPr>
+              <a:lnSpc>
+                <a:spcPct val="115000"/>
+              </a:lnSpc>
+              <a:spcBef>
+                <a:spcPts val="800"/>
+              </a:spcBef>
+              <a:spcAft>
+                <a:spcPts val="800"/>
+              </a:spcAft>
+              <a:defRPr sz="1800">
+                <a:solidFill>
+                  <a:srgbClr val="282828"/>
+                </a:solidFill>
+              </a:defRPr>
+            </a:pPr>
+            <a:r>
+              <a:t>● Result: no strong disparate impact detected</a:t>
+            </a:r>
+          </a:p>
+          <a:p>
+            <a:pPr>
+              <a:lnSpc>
+                <a:spcPct val="115000"/>
+              </a:lnSpc>
+              <a:spcBef>
+                <a:spcPts val="800"/>
+              </a:spcBef>
+              <a:spcAft>
+                <a:spcPts val="800"/>
+              </a:spcAft>
+              <a:defRPr sz="1800">
+                <a:solidFill>
+                  <a:srgbClr val="282828"/>
+                </a:solidFill>
+              </a:defRPr>
+            </a:pPr>
+            <a:r>
+              <a:t>● Transparency: audit results logged and documented</a:t>
             </a:r>
           </a:p>
         </p:txBody>
@@ -3599,6 +4164,14 @@
 <file path=ppt/slides/slide6.xml><?xml version="1.0" encoding="utf-8"?>
 <p:sld xmlns:a="http://schemas.openxmlformats.org/drawingml/2006/main" xmlns:p="http://schemas.openxmlformats.org/presentationml/2006/main" xmlns:r="http://schemas.openxmlformats.org/officeDocument/2006/relationships">
   <p:cSld>
+    <p:bg>
+      <p:bgPr>
+        <a:solidFill>
+          <a:srgbClr val="FFFFFF"/>
+        </a:solidFill>
+        <a:effectLst/>
+      </p:bgPr>
+    </p:bg>
     <p:spTree>
       <p:nvGrpSpPr>
         <p:cNvPr id="1" name=""/>
@@ -3608,19 +4181,47 @@
       <p:grpSpPr/>
       <p:sp>
         <p:nvSpPr>
-          <p:cNvPr id="2" name="Title 1"/>
-          <p:cNvSpPr>
-            <a:spLocks noGrp="1"/>
-          </p:cNvSpPr>
-          <p:nvPr>
-            <p:ph type="title"/>
-          </p:nvPr>
-        </p:nvSpPr>
-        <p:spPr/>
-        <p:txBody>
-          <a:bodyPr/>
-          <a:lstStyle/>
-          <a:p/>
+          <p:cNvPr id="2" name="Rectangle 1"/>
+          <p:cNvSpPr/>
+          <p:nvPr/>
+        </p:nvSpPr>
+        <p:spPr>
+          <a:xfrm>
+            <a:off x="0" y="0"/>
+            <a:ext cx="9144000" cy="914400"/>
+          </a:xfrm>
+          <a:prstGeom prst="rect">
+            <a:avLst/>
+          </a:prstGeom>
+          <a:solidFill>
+            <a:srgbClr val="19345F"/>
+          </a:solidFill>
+          <a:ln>
+            <a:solidFill>
+              <a:srgbClr val="19345F"/>
+            </a:solidFill>
+          </a:ln>
+        </p:spPr>
+        <p:style>
+          <a:lnRef idx="1">
+            <a:schemeClr val="accent1"/>
+          </a:lnRef>
+          <a:fillRef idx="3">
+            <a:schemeClr val="accent1"/>
+          </a:fillRef>
+          <a:effectRef idx="2">
+            <a:schemeClr val="accent1"/>
+          </a:effectRef>
+          <a:fontRef idx="minor">
+            <a:schemeClr val="lt1"/>
+          </a:fontRef>
+        </p:style>
+        <p:txBody>
+          <a:bodyPr rtlCol="0" anchor="ctr"/>
+          <a:lstStyle/>
+          <a:p>
+            <a:pPr algn="ctr"/>
+          </a:p>
         </p:txBody>
       </p:sp>
       <p:sp>
@@ -3631,8 +4232,8 @@
         </p:nvSpPr>
         <p:spPr>
           <a:xfrm>
-            <a:off x="457200" y="457200"/>
-            <a:ext cx="8229600" cy="1143000"/>
+            <a:off x="457200" y="137160"/>
+            <a:ext cx="8229600" cy="640080"/>
           </a:xfrm>
           <a:prstGeom prst="rect">
             <a:avLst/>
@@ -3646,7 +4247,11 @@
           <a:lstStyle/>
           <a:p>
             <a:pPr>
-              <a:defRPr sz="3200"/>
+              <a:defRPr sz="4000" b="1">
+                <a:solidFill>
+                  <a:srgbClr val="FFFFFF"/>
+                </a:solidFill>
+              </a:defRPr>
             </a:pPr>
             <a:r>
               <a:t>Final Verdict &amp; Q&amp;A</a:t>
@@ -3662,8 +4267,8 @@
         </p:nvSpPr>
         <p:spPr>
           <a:xfrm>
-            <a:off x="457200" y="1600200"/>
-            <a:ext cx="8229600" cy="3657600"/>
+            <a:off x="685800" y="1188720"/>
+            <a:ext cx="7772400" cy="5303520"/>
           </a:xfrm>
           <a:prstGeom prst="rect">
             <a:avLst/>
@@ -3671,31 +4276,113 @@
           <a:noFill/>
         </p:spPr>
         <p:txBody>
-          <a:bodyPr wrap="none">
+          <a:bodyPr wrap="square">
             <a:spAutoFit/>
           </a:bodyPr>
           <a:lstStyle/>
           <a:p>
             <a:pPr>
-              <a:defRPr sz="2000"/>
+              <a:lnSpc>
+                <a:spcPct val="115000"/>
+              </a:lnSpc>
+              <a:spcBef>
+                <a:spcPts val="800"/>
+              </a:spcBef>
+              <a:spcAft>
+                <a:spcPts val="800"/>
+              </a:spcAft>
+              <a:defRPr sz="1800">
+                <a:solidFill>
+                  <a:srgbClr val="282828"/>
+                </a:solidFill>
+              </a:defRPr>
             </a:pPr>
             <a:r>
-              <a:t>● Predicted Software Engineering mark: 85.8</a:t>
-            </a:r>
-          </a:p>
-          <a:p>
-            <a:r>
-              <a:t>● Expected error margin: ±5.0</a:t>
-            </a:r>
-          </a:p>
-          <a:p>
-            <a:r>
-              <a:t>● The model is ready for submission with documented validation and ethical safeguards.</a:t>
-            </a:r>
-          </a:p>
-          <a:p>
-            <a:r>
-              <a:t>● Questions: model selection, privacy, accuracy, or future improvements.</a:t>
+              <a:t>● Predicted Software Engineering Mark: 85.8 / 100</a:t>
+            </a:r>
+          </a:p>
+          <a:p>
+            <a:pPr>
+              <a:lnSpc>
+                <a:spcPct val="115000"/>
+              </a:lnSpc>
+              <a:spcBef>
+                <a:spcPts val="800"/>
+              </a:spcBef>
+              <a:spcAft>
+                <a:spcPts val="800"/>
+              </a:spcAft>
+              <a:defRPr sz="1800">
+                <a:solidFill>
+                  <a:srgbClr val="282828"/>
+                </a:solidFill>
+              </a:defRPr>
+            </a:pPr>
+            <a:r>
+              <a:t>● Confidence Interval: ±5.0 marks</a:t>
+            </a:r>
+          </a:p>
+          <a:p>
+            <a:pPr>
+              <a:lnSpc>
+                <a:spcPct val="115000"/>
+              </a:lnSpc>
+              <a:spcBef>
+                <a:spcPts val="800"/>
+              </a:spcBef>
+              <a:spcAft>
+                <a:spcPts val="800"/>
+              </a:spcAft>
+              <a:defRPr sz="1800">
+                <a:solidFill>
+                  <a:srgbClr val="282828"/>
+                </a:solidFill>
+              </a:defRPr>
+            </a:pPr>
+            <a:r>
+              <a:t>● Model Status: validated, tested, ethically audited</a:t>
+            </a:r>
+          </a:p>
+          <a:p>
+            <a:pPr>
+              <a:lnSpc>
+                <a:spcPct val="115000"/>
+              </a:lnSpc>
+              <a:spcBef>
+                <a:spcPts val="800"/>
+              </a:spcBef>
+              <a:spcAft>
+                <a:spcPts val="800"/>
+              </a:spcAft>
+              <a:defRPr sz="1800">
+                <a:solidFill>
+                  <a:srgbClr val="282828"/>
+                </a:solidFill>
+              </a:defRPr>
+            </a:pPr>
+            <a:r>
+              <a:t>● Submission Components: Code, Documentation, Cleaned Data</a:t>
+            </a:r>
+          </a:p>
+          <a:p>
+            <a:pPr>
+              <a:lnSpc>
+                <a:spcPct val="115000"/>
+              </a:lnSpc>
+              <a:spcBef>
+                <a:spcPts val="800"/>
+              </a:spcBef>
+              <a:spcAft>
+                <a:spcPts val="800"/>
+              </a:spcAft>
+              <a:defRPr sz="1800">
+                <a:solidFill>
+                  <a:srgbClr val="282828"/>
+                </a:solidFill>
+              </a:defRPr>
+            </a:pPr>
+            <a:r>
+              <a:t>● Questions? Ask about methodology, privacy, accuracy, or improvements</a:t>
             </a:r>
           </a:p>
         </p:txBody>

</xml_diff>

<commit_message>
Create presentation with Security Audit styling applied to Academic Predictor content
</commit_message>
<xml_diff>
--- a/Academic Predictor Presentation.pptx
+++ b/Academic Predictor Presentation.pptx
@@ -11,6 +11,7 @@
     <p:sldId id="259" r:id="rId10"/>
     <p:sldId id="260" r:id="rId11"/>
     <p:sldId id="261" r:id="rId12"/>
+    <p:sldId id="262" r:id="rId13"/>
   </p:sldIdLst>
   <p:sldSz cx="9144000" cy="6858000" type="screen4x3"/>
   <p:notesSz cx="6858000" cy="9144000"/>
@@ -3086,14 +3087,6 @@
 <file path=ppt/slides/slide1.xml><?xml version="1.0" encoding="utf-8"?>
 <p:sld xmlns:a="http://schemas.openxmlformats.org/drawingml/2006/main" xmlns:p="http://schemas.openxmlformats.org/presentationml/2006/main" xmlns:r="http://schemas.openxmlformats.org/officeDocument/2006/relationships">
   <p:cSld>
-    <p:bg>
-      <p:bgPr>
-        <a:solidFill>
-          <a:srgbClr val="19345F"/>
-        </a:solidFill>
-        <a:effectLst/>
-      </p:bgPr>
-    </p:bg>
     <p:spTree>
       <p:nvGrpSpPr>
         <p:cNvPr id="1" name=""/>
@@ -3109,8 +3102,8 @@
         </p:nvSpPr>
         <p:spPr>
           <a:xfrm>
-            <a:off x="457200" y="2286000"/>
-            <a:ext cx="8229600" cy="1371600"/>
+            <a:off x="457200" y="914400"/>
+            <a:ext cx="8229600" cy="1097280"/>
           </a:xfrm>
           <a:prstGeom prst="rect">
             <a:avLst/>
@@ -3118,22 +3111,19 @@
           <a:noFill/>
         </p:spPr>
         <p:txBody>
-          <a:bodyPr wrap="square">
+          <a:bodyPr wrap="none">
             <a:spAutoFit/>
           </a:bodyPr>
           <a:lstStyle/>
           <a:p>
-            <a:pPr algn="ctr">
+            <a:pPr algn="l">
               <a:defRPr sz="5400" b="1">
                 <a:solidFill>
-                  <a:srgbClr val="FFFFFF"/>
-                </a:solidFill>
+                  <a:srgbClr val="6366F1"/>
+                </a:solidFill>
+                <a:latin typeface="Calibri"/>
               </a:defRPr>
             </a:pPr>
-            <a:r>
-              <a:t>The Multi-Subject</a:t>
-            </a:r>
-            <a:br/>
             <a:r>
               <a:t>Academic Predictor</a:t>
             </a:r>
@@ -3148,8 +3138,8 @@
         </p:nvSpPr>
         <p:spPr>
           <a:xfrm>
-            <a:off x="457200" y="3840480"/>
-            <a:ext cx="8229600" cy="2286000"/>
+            <a:off x="457200" y="1828800"/>
+            <a:ext cx="8229600" cy="731520"/>
           </a:xfrm>
           <a:prstGeom prst="rect">
             <a:avLst/>
@@ -3162,57 +3152,103 @@
           </a:bodyPr>
           <a:lstStyle/>
           <a:p>
-            <a:pPr algn="ctr">
-              <a:spcBef>
-                <a:spcPts val="600"/>
-              </a:spcBef>
+            <a:pPr algn="l">
+              <a:defRPr sz="2200">
+                <a:solidFill>
+                  <a:srgbClr val="DCDCE6"/>
+                </a:solidFill>
+                <a:latin typeface="Calibri"/>
+              </a:defRPr>
+            </a:pPr>
+            <a:r>
+              <a:t>Multi-feature linear regression for predicting student final grades</a:t>
+            </a:r>
+          </a:p>
+        </p:txBody>
+      </p:sp>
+      <p:sp>
+        <p:nvSpPr>
+          <p:cNvPr id="4" name="TextBox 3"/>
+          <p:cNvSpPr txBox="1"/>
+          <p:nvPr/>
+        </p:nvSpPr>
+        <p:spPr>
+          <a:xfrm>
+            <a:off x="457200" y="2926080"/>
+            <a:ext cx="8229600" cy="4114800"/>
+          </a:xfrm>
+          <a:prstGeom prst="rect">
+            <a:avLst/>
+          </a:prstGeom>
+          <a:noFill/>
+        </p:spPr>
+        <p:txBody>
+          <a:bodyPr wrap="square">
+            <a:spAutoFit/>
+          </a:bodyPr>
+          <a:lstStyle/>
+          <a:p>
+            <a:pPr algn="l">
               <a:spcAft>
-                <a:spcPts val="600"/>
+                <a:spcPts val="800"/>
               </a:spcAft>
-              <a:defRPr sz="2400">
-                <a:solidFill>
-                  <a:srgbClr val="F0F0F0"/>
-                </a:solidFill>
+              <a:defRPr sz="1800">
+                <a:solidFill>
+                  <a:srgbClr val="1E1E2E"/>
+                </a:solidFill>
+                <a:latin typeface="Calibri"/>
               </a:defRPr>
             </a:pPr>
             <a:r>
-              <a:t>Target Student: Alex Anderson</a:t>
-            </a:r>
-          </a:p>
-          <a:p>
-            <a:pPr algn="ctr">
-              <a:spcBef>
-                <a:spcPts val="600"/>
-              </a:spcBef>
+              <a:t>Automated data cleaning &amp; validation</a:t>
+            </a:r>
+          </a:p>
+          <a:p>
+            <a:pPr algn="l">
               <a:spcAft>
-                <a:spcPts val="600"/>
+                <a:spcPts val="800"/>
               </a:spcAft>
-              <a:defRPr sz="2400">
-                <a:solidFill>
-                  <a:srgbClr val="F0F0F0"/>
-                </a:solidFill>
+              <a:defRPr sz="1800">
+                <a:solidFill>
+                  <a:srgbClr val="1E1E2E"/>
+                </a:solidFill>
+                <a:latin typeface="Calibri"/>
               </a:defRPr>
             </a:pPr>
             <a:r>
-              <a:t>Missing Subject: Software Engineering</a:t>
-            </a:r>
-          </a:p>
-          <a:p>
-            <a:pPr algn="ctr">
-              <a:spcBef>
-                <a:spcPts val="600"/>
-              </a:spcBef>
+              <a:t>Supervised learning with train-test split</a:t>
+            </a:r>
+          </a:p>
+          <a:p>
+            <a:pPr algn="l">
               <a:spcAft>
-                <a:spcPts val="600"/>
+                <a:spcPts val="800"/>
               </a:spcAft>
-              <a:defRPr sz="2400">
-                <a:solidFill>
-                  <a:srgbClr val="F0F0F0"/>
-                </a:solidFill>
+              <a:defRPr sz="1800">
+                <a:solidFill>
+                  <a:srgbClr val="1E1E2E"/>
+                </a:solidFill>
+                <a:latin typeface="Calibri"/>
               </a:defRPr>
             </a:pPr>
             <a:r>
-              <a:t>HSC Software Engineering (Stage 6)</a:t>
+              <a:t>Cross-validation &amp; RMSE evaluation</a:t>
+            </a:r>
+          </a:p>
+          <a:p>
+            <a:pPr algn="l">
+              <a:spcAft>
+                <a:spcPts val="800"/>
+              </a:spcAft>
+              <a:defRPr sz="1800">
+                <a:solidFill>
+                  <a:srgbClr val="1E1E2E"/>
+                </a:solidFill>
+                <a:latin typeface="Calibri"/>
+              </a:defRPr>
+            </a:pPr>
+            <a:r>
+              <a:t>Privacy-aware data handling &amp; bias audit</a:t>
             </a:r>
           </a:p>
         </p:txBody>
@@ -3228,14 +3264,6 @@
 <file path=ppt/slides/slide2.xml><?xml version="1.0" encoding="utf-8"?>
 <p:sld xmlns:a="http://schemas.openxmlformats.org/drawingml/2006/main" xmlns:p="http://schemas.openxmlformats.org/presentationml/2006/main" xmlns:r="http://schemas.openxmlformats.org/officeDocument/2006/relationships">
   <p:cSld>
-    <p:bg>
-      <p:bgPr>
-        <a:solidFill>
-          <a:srgbClr val="FFFFFF"/>
-        </a:solidFill>
-        <a:effectLst/>
-      </p:bgPr>
-    </p:bg>
     <p:spTree>
       <p:nvGrpSpPr>
         <p:cNvPr id="1" name=""/>
@@ -3245,24 +3273,60 @@
       <p:grpSpPr/>
       <p:sp>
         <p:nvSpPr>
-          <p:cNvPr id="2" name="Rectangle 1"/>
+          <p:cNvPr id="2" name="TextBox 1"/>
+          <p:cNvSpPr txBox="1"/>
+          <p:nvPr/>
+        </p:nvSpPr>
+        <p:spPr>
+          <a:xfrm>
+            <a:off x="457200" y="457200"/>
+            <a:ext cx="8229600" cy="1097280"/>
+          </a:xfrm>
+          <a:prstGeom prst="rect">
+            <a:avLst/>
+          </a:prstGeom>
+          <a:noFill/>
+        </p:spPr>
+        <p:txBody>
+          <a:bodyPr wrap="none">
+            <a:spAutoFit/>
+          </a:bodyPr>
+          <a:lstStyle/>
+          <a:p>
+            <a:pPr algn="l">
+              <a:defRPr sz="4000" b="1">
+                <a:solidFill>
+                  <a:srgbClr val="1E1E2E"/>
+                </a:solidFill>
+                <a:latin typeface="Calibri"/>
+              </a:defRPr>
+            </a:pPr>
+            <a:r>
+              <a:t>Agenda</a:t>
+            </a:r>
+          </a:p>
+        </p:txBody>
+      </p:sp>
+      <p:sp>
+        <p:nvSpPr>
+          <p:cNvPr id="3" name="Rectangle 2"/>
           <p:cNvSpPr/>
           <p:nvPr/>
         </p:nvSpPr>
         <p:spPr>
           <a:xfrm>
-            <a:off x="0" y="0"/>
-            <a:ext cx="9144000" cy="914400"/>
+            <a:off x="457200" y="1097280"/>
+            <a:ext cx="8229600" cy="18288"/>
           </a:xfrm>
           <a:prstGeom prst="rect">
             <a:avLst/>
           </a:prstGeom>
           <a:solidFill>
-            <a:srgbClr val="19345F"/>
+            <a:srgbClr val="6366F1"/>
           </a:solidFill>
           <a:ln>
             <a:solidFill>
-              <a:srgbClr val="19345F"/>
+              <a:srgbClr val="6366F1"/>
             </a:solidFill>
           </a:ln>
         </p:spPr>
@@ -3290,14 +3354,14 @@
       </p:sp>
       <p:sp>
         <p:nvSpPr>
-          <p:cNvPr id="3" name="TextBox 2"/>
+          <p:cNvPr id="4" name="TextBox 3"/>
           <p:cNvSpPr txBox="1"/>
           <p:nvPr/>
         </p:nvSpPr>
         <p:spPr>
           <a:xfrm>
-            <a:off x="457200" y="137160"/>
-            <a:ext cx="8229600" cy="640080"/>
+            <a:off x="457200" y="1463040"/>
+            <a:ext cx="8229600" cy="4114800"/>
           </a:xfrm>
           <a:prstGeom prst="rect">
             <a:avLst/>
@@ -3305,148 +3369,88 @@
           <a:noFill/>
         </p:spPr>
         <p:txBody>
-          <a:bodyPr wrap="none">
-            <a:spAutoFit/>
-          </a:bodyPr>
-          <a:lstStyle/>
-          <a:p>
-            <a:pPr>
-              <a:defRPr sz="4000" b="1">
-                <a:solidFill>
-                  <a:srgbClr val="FFFFFF"/>
-                </a:solidFill>
-              </a:defRPr>
-            </a:pPr>
-            <a:r>
-              <a:t>Mathematical Justification</a:t>
-            </a:r>
-          </a:p>
-        </p:txBody>
-      </p:sp>
-      <p:sp>
-        <p:nvSpPr>
-          <p:cNvPr id="4" name="TextBox 3"/>
-          <p:cNvSpPr txBox="1"/>
-          <p:nvPr/>
-        </p:nvSpPr>
-        <p:spPr>
-          <a:xfrm>
-            <a:off x="685800" y="1188720"/>
-            <a:ext cx="7772400" cy="5303520"/>
-          </a:xfrm>
-          <a:prstGeom prst="rect">
-            <a:avLst/>
-          </a:prstGeom>
-          <a:noFill/>
-        </p:spPr>
-        <p:txBody>
           <a:bodyPr wrap="square">
             <a:spAutoFit/>
           </a:bodyPr>
           <a:lstStyle/>
           <a:p>
-            <a:pPr>
-              <a:lnSpc>
-                <a:spcPct val="115000"/>
-              </a:lnSpc>
-              <a:spcBef>
-                <a:spcPts val="800"/>
-              </a:spcBef>
+            <a:pPr algn="l">
               <a:spcAft>
                 <a:spcPts val="800"/>
               </a:spcAft>
-              <a:defRPr sz="1800">
-                <a:solidFill>
-                  <a:srgbClr val="282828"/>
-                </a:solidFill>
+              <a:defRPr sz="2000">
+                <a:solidFill>
+                  <a:srgbClr val="1E1E2E"/>
+                </a:solidFill>
+                <a:latin typeface="Calibri"/>
               </a:defRPr>
             </a:pPr>
             <a:r>
-              <a:t>● Algorithm: Linear Regression with StandardScaler</a:t>
-            </a:r>
-          </a:p>
-          <a:p>
-            <a:pPr>
-              <a:lnSpc>
-                <a:spcPct val="115000"/>
-              </a:lnSpc>
-              <a:spcBef>
-                <a:spcPts val="800"/>
-              </a:spcBef>
+              <a:t>1.  Dataset overview &amp; cleaning strategy</a:t>
+            </a:r>
+          </a:p>
+          <a:p>
+            <a:pPr algn="l">
               <a:spcAft>
                 <a:spcPts val="800"/>
               </a:spcAft>
-              <a:defRPr sz="1800">
-                <a:solidFill>
-                  <a:srgbClr val="282828"/>
-                </a:solidFill>
+              <a:defRPr sz="2000">
+                <a:solidFill>
+                  <a:srgbClr val="1E1E2E"/>
+                </a:solidFill>
+                <a:latin typeface="Calibri"/>
               </a:defRPr>
             </a:pPr>
             <a:r>
-              <a:t>● Features: Maths Advanced, Physics, Modern History</a:t>
-            </a:r>
-          </a:p>
-          <a:p>
-            <a:pPr>
-              <a:lnSpc>
-                <a:spcPct val="115000"/>
-              </a:lnSpc>
-              <a:spcBef>
-                <a:spcPts val="800"/>
-              </a:spcBef>
+              <a:t>2.  Baseline vs. multi-feature modeling</a:t>
+            </a:r>
+          </a:p>
+          <a:p>
+            <a:pPr algn="l">
               <a:spcAft>
                 <a:spcPts val="800"/>
               </a:spcAft>
-              <a:defRPr sz="1800">
-                <a:solidFill>
-                  <a:srgbClr val="282828"/>
-                </a:solidFill>
+              <a:defRPr sz="2000">
+                <a:solidFill>
+                  <a:srgbClr val="1E1E2E"/>
+                </a:solidFill>
+                <a:latin typeface="Calibri"/>
               </a:defRPr>
             </a:pPr>
             <a:r>
-              <a:t>● Why ML? Captures subject correlations for fairer prediction than flat averaging</a:t>
-            </a:r>
-          </a:p>
-          <a:p>
-            <a:pPr>
-              <a:lnSpc>
-                <a:spcPct val="115000"/>
-              </a:lnSpc>
-              <a:spcBef>
-                <a:spcPts val="800"/>
-              </a:spcBef>
+              <a:t>3.  Validation results &amp; prediction accuracy</a:t>
+            </a:r>
+          </a:p>
+          <a:p>
+            <a:pPr algn="l">
               <a:spcAft>
                 <a:spcPts val="800"/>
               </a:spcAft>
-              <a:defRPr sz="1800">
-                <a:solidFill>
-                  <a:srgbClr val="282828"/>
-                </a:solidFill>
+              <a:defRPr sz="2000">
+                <a:solidFill>
+                  <a:srgbClr val="1E1E2E"/>
+                </a:solidFill>
+                <a:latin typeface="Calibri"/>
               </a:defRPr>
             </a:pPr>
             <a:r>
-              <a:t>● Libraries: pandas, numpy, scikit-learn, python-docx, python-pptx</a:t>
-            </a:r>
-          </a:p>
-          <a:p>
-            <a:pPr>
-              <a:lnSpc>
-                <a:spcPct val="115000"/>
-              </a:lnSpc>
-              <a:spcBef>
-                <a:spcPts val="800"/>
-              </a:spcBef>
+              <a:t>4.  Bias audit &amp; ethical safeguards</a:t>
+            </a:r>
+          </a:p>
+          <a:p>
+            <a:pPr algn="l">
               <a:spcAft>
                 <a:spcPts val="800"/>
               </a:spcAft>
-              <a:defRPr sz="1800">
-                <a:solidFill>
-                  <a:srgbClr val="282828"/>
-                </a:solidFill>
+              <a:defRPr sz="2000">
+                <a:solidFill>
+                  <a:srgbClr val="1E1E2E"/>
+                </a:solidFill>
+                <a:latin typeface="Calibri"/>
               </a:defRPr>
             </a:pPr>
             <a:r>
-              <a:t>● Benefit: Mathematically rigorous and objective grade estimation</a:t>
+              <a:t>5.  Submission readiness &amp; summary</a:t>
             </a:r>
           </a:p>
         </p:txBody>
@@ -3462,14 +3466,6 @@
 <file path=ppt/slides/slide3.xml><?xml version="1.0" encoding="utf-8"?>
 <p:sld xmlns:a="http://schemas.openxmlformats.org/drawingml/2006/main" xmlns:p="http://schemas.openxmlformats.org/presentationml/2006/main" xmlns:r="http://schemas.openxmlformats.org/officeDocument/2006/relationships">
   <p:cSld>
-    <p:bg>
-      <p:bgPr>
-        <a:solidFill>
-          <a:srgbClr val="FFFFFF"/>
-        </a:solidFill>
-        <a:effectLst/>
-      </p:bgPr>
-    </p:bg>
     <p:spTree>
       <p:nvGrpSpPr>
         <p:cNvPr id="1" name=""/>
@@ -3479,24 +3475,60 @@
       <p:grpSpPr/>
       <p:sp>
         <p:nvSpPr>
-          <p:cNvPr id="2" name="Rectangle 1"/>
+          <p:cNvPr id="2" name="TextBox 1"/>
+          <p:cNvSpPr txBox="1"/>
+          <p:nvPr/>
+        </p:nvSpPr>
+        <p:spPr>
+          <a:xfrm>
+            <a:off x="457200" y="457200"/>
+            <a:ext cx="8229600" cy="1097280"/>
+          </a:xfrm>
+          <a:prstGeom prst="rect">
+            <a:avLst/>
+          </a:prstGeom>
+          <a:noFill/>
+        </p:spPr>
+        <p:txBody>
+          <a:bodyPr wrap="none">
+            <a:spAutoFit/>
+          </a:bodyPr>
+          <a:lstStyle/>
+          <a:p>
+            <a:pPr algn="l">
+              <a:defRPr sz="4000" b="1">
+                <a:solidFill>
+                  <a:srgbClr val="1E1E2E"/>
+                </a:solidFill>
+                <a:latin typeface="Calibri"/>
+              </a:defRPr>
+            </a:pPr>
+            <a:r>
+              <a:t>Dataset Overview</a:t>
+            </a:r>
+          </a:p>
+        </p:txBody>
+      </p:sp>
+      <p:sp>
+        <p:nvSpPr>
+          <p:cNvPr id="3" name="Rectangle 2"/>
           <p:cNvSpPr/>
           <p:nvPr/>
         </p:nvSpPr>
         <p:spPr>
           <a:xfrm>
-            <a:off x="0" y="0"/>
-            <a:ext cx="9144000" cy="914400"/>
+            <a:off x="457200" y="1097280"/>
+            <a:ext cx="8229600" cy="18288"/>
           </a:xfrm>
           <a:prstGeom prst="rect">
             <a:avLst/>
           </a:prstGeom>
           <a:solidFill>
-            <a:srgbClr val="19345F"/>
+            <a:srgbClr val="6366F1"/>
           </a:solidFill>
           <a:ln>
             <a:solidFill>
-              <a:srgbClr val="19345F"/>
+              <a:srgbClr val="6366F1"/>
             </a:solidFill>
           </a:ln>
         </p:spPr>
@@ -3524,14 +3556,14 @@
       </p:sp>
       <p:sp>
         <p:nvSpPr>
-          <p:cNvPr id="3" name="TextBox 2"/>
+          <p:cNvPr id="4" name="TextBox 3"/>
           <p:cNvSpPr txBox="1"/>
           <p:nvPr/>
         </p:nvSpPr>
         <p:spPr>
           <a:xfrm>
-            <a:off x="457200" y="137160"/>
-            <a:ext cx="8229600" cy="640080"/>
+            <a:off x="457200" y="1463040"/>
+            <a:ext cx="8229600" cy="4114800"/>
           </a:xfrm>
           <a:prstGeom prst="rect">
             <a:avLst/>
@@ -3539,148 +3571,88 @@
           <a:noFill/>
         </p:spPr>
         <p:txBody>
-          <a:bodyPr wrap="none">
-            <a:spAutoFit/>
-          </a:bodyPr>
-          <a:lstStyle/>
-          <a:p>
-            <a:pPr>
-              <a:defRPr sz="4000" b="1">
-                <a:solidFill>
-                  <a:srgbClr val="FFFFFF"/>
-                </a:solidFill>
-              </a:defRPr>
-            </a:pPr>
-            <a:r>
-              <a:t>Visual Proof of Accuracy</a:t>
-            </a:r>
-          </a:p>
-        </p:txBody>
-      </p:sp>
-      <p:sp>
-        <p:nvSpPr>
-          <p:cNvPr id="4" name="TextBox 3"/>
-          <p:cNvSpPr txBox="1"/>
-          <p:nvPr/>
-        </p:nvSpPr>
-        <p:spPr>
-          <a:xfrm>
-            <a:off x="685800" y="1188720"/>
-            <a:ext cx="7772400" cy="5303520"/>
-          </a:xfrm>
-          <a:prstGeom prst="rect">
-            <a:avLst/>
-          </a:prstGeom>
-          <a:noFill/>
-        </p:spPr>
-        <p:txBody>
           <a:bodyPr wrap="square">
             <a:spAutoFit/>
           </a:bodyPr>
           <a:lstStyle/>
           <a:p>
-            <a:pPr>
-              <a:lnSpc>
-                <a:spcPct val="115000"/>
-              </a:lnSpc>
-              <a:spcBef>
-                <a:spcPts val="800"/>
-              </a:spcBef>
+            <a:pPr algn="l">
               <a:spcAft>
                 <a:spcPts val="800"/>
               </a:spcAft>
               <a:defRPr sz="1800">
                 <a:solidFill>
-                  <a:srgbClr val="282828"/>
-                </a:solidFill>
+                  <a:srgbClr val="1E1E2E"/>
+                </a:solidFill>
+                <a:latin typeface="Calibri"/>
               </a:defRPr>
             </a:pPr>
             <a:r>
-              <a:t>● Test Set RMSE: 4.96 marks</a:t>
-            </a:r>
-          </a:p>
-          <a:p>
-            <a:pPr>
-              <a:lnSpc>
-                <a:spcPct val="115000"/>
-              </a:lnSpc>
-              <a:spcBef>
-                <a:spcPts val="800"/>
-              </a:spcBef>
+              <a:t>Original dataset: 28 student records</a:t>
+            </a:r>
+          </a:p>
+          <a:p>
+            <a:pPr algn="l">
               <a:spcAft>
                 <a:spcPts val="800"/>
               </a:spcAft>
               <a:defRPr sz="1800">
                 <a:solidFill>
-                  <a:srgbClr val="282828"/>
-                </a:solidFill>
+                  <a:srgbClr val="1E1E2E"/>
+                </a:solidFill>
+                <a:latin typeface="Calibri"/>
               </a:defRPr>
             </a:pPr>
             <a:r>
-              <a:t>● 5-Fold Cross-Validation RMSE: 3.45 marks</a:t>
-            </a:r>
-          </a:p>
-          <a:p>
-            <a:pPr>
-              <a:lnSpc>
-                <a:spcPct val="115000"/>
-              </a:lnSpc>
-              <a:spcBef>
-                <a:spcPts val="800"/>
-              </a:spcBef>
+              <a:t>Cleaned dataset: 21 valid rows (removed missing/invalid scores)</a:t>
+            </a:r>
+          </a:p>
+          <a:p>
+            <a:pPr algn="l">
               <a:spcAft>
                 <a:spcPts val="800"/>
               </a:spcAft>
               <a:defRPr sz="1800">
                 <a:solidFill>
-                  <a:srgbClr val="282828"/>
-                </a:solidFill>
+                  <a:srgbClr val="1E1E2E"/>
+                </a:solidFill>
+                <a:latin typeface="Calibri"/>
               </a:defRPr>
             </a:pPr>
             <a:r>
-              <a:t>● Predicted Score (Alex): 85.8 / 100</a:t>
-            </a:r>
-          </a:p>
-          <a:p>
-            <a:pPr>
-              <a:lnSpc>
-                <a:spcPct val="115000"/>
-              </a:lnSpc>
-              <a:spcBef>
-                <a:spcPts val="800"/>
-              </a:spcBef>
+              <a:t>Feature columns: Maths Advanced, Physics, Modern History</a:t>
+            </a:r>
+          </a:p>
+          <a:p>
+            <a:pPr algn="l">
               <a:spcAft>
                 <a:spcPts val="800"/>
               </a:spcAft>
               <a:defRPr sz="1800">
                 <a:solidFill>
-                  <a:srgbClr val="282828"/>
-                </a:solidFill>
+                  <a:srgbClr val="1E1E2E"/>
+                </a:solidFill>
+                <a:latin typeface="Calibri"/>
               </a:defRPr>
             </a:pPr>
             <a:r>
-              <a:t>● Expected Error Margin: ±5.0 marks</a:t>
-            </a:r>
-          </a:p>
-          <a:p>
-            <a:pPr>
-              <a:lnSpc>
-                <a:spcPct val="115000"/>
-              </a:lnSpc>
-              <a:spcBef>
-                <a:spcPts val="800"/>
-              </a:spcBef>
+              <a:t>Target column: Software Engineering Final Grade (0–100)</a:t>
+            </a:r>
+          </a:p>
+          <a:p>
+            <a:pPr algn="l">
               <a:spcAft>
                 <a:spcPts val="800"/>
               </a:spcAft>
               <a:defRPr sz="1800">
                 <a:solidFill>
-                  <a:srgbClr val="282828"/>
-                </a:solidFill>
+                  <a:srgbClr val="1E1E2E"/>
+                </a:solidFill>
+                <a:latin typeface="Calibri"/>
               </a:defRPr>
             </a:pPr>
             <a:r>
-              <a:t>● Assessment: Error margin is acceptable for formative grade prediction</a:t>
+              <a:t>Cleaning rules: drop NaN, enforce [0, 100] range per column</a:t>
             </a:r>
           </a:p>
         </p:txBody>
@@ -3696,14 +3668,6 @@
 <file path=ppt/slides/slide4.xml><?xml version="1.0" encoding="utf-8"?>
 <p:sld xmlns:a="http://schemas.openxmlformats.org/drawingml/2006/main" xmlns:p="http://schemas.openxmlformats.org/presentationml/2006/main" xmlns:r="http://schemas.openxmlformats.org/officeDocument/2006/relationships">
   <p:cSld>
-    <p:bg>
-      <p:bgPr>
-        <a:solidFill>
-          <a:srgbClr val="FFFFFF"/>
-        </a:solidFill>
-        <a:effectLst/>
-      </p:bgPr>
-    </p:bg>
     <p:spTree>
       <p:nvGrpSpPr>
         <p:cNvPr id="1" name=""/>
@@ -3713,24 +3677,60 @@
       <p:grpSpPr/>
       <p:sp>
         <p:nvSpPr>
-          <p:cNvPr id="2" name="Rectangle 1"/>
+          <p:cNvPr id="2" name="TextBox 1"/>
+          <p:cNvSpPr txBox="1"/>
+          <p:nvPr/>
+        </p:nvSpPr>
+        <p:spPr>
+          <a:xfrm>
+            <a:off x="457200" y="457200"/>
+            <a:ext cx="8229600" cy="1097280"/>
+          </a:xfrm>
+          <a:prstGeom prst="rect">
+            <a:avLst/>
+          </a:prstGeom>
+          <a:noFill/>
+        </p:spPr>
+        <p:txBody>
+          <a:bodyPr wrap="none">
+            <a:spAutoFit/>
+          </a:bodyPr>
+          <a:lstStyle/>
+          <a:p>
+            <a:pPr algn="l">
+              <a:defRPr sz="3800" b="1">
+                <a:solidFill>
+                  <a:srgbClr val="1E1E2E"/>
+                </a:solidFill>
+                <a:latin typeface="Calibri"/>
+              </a:defRPr>
+            </a:pPr>
+            <a:r>
+              <a:t>Model Strategy: Baseline vs. Level 2</a:t>
+            </a:r>
+          </a:p>
+        </p:txBody>
+      </p:sp>
+      <p:sp>
+        <p:nvSpPr>
+          <p:cNvPr id="3" name="Rectangle 2"/>
           <p:cNvSpPr/>
           <p:nvPr/>
         </p:nvSpPr>
         <p:spPr>
           <a:xfrm>
-            <a:off x="0" y="0"/>
-            <a:ext cx="9144000" cy="914400"/>
+            <a:off x="457200" y="1097280"/>
+            <a:ext cx="8229600" cy="18288"/>
           </a:xfrm>
           <a:prstGeom prst="rect">
             <a:avLst/>
           </a:prstGeom>
           <a:solidFill>
-            <a:srgbClr val="19345F"/>
+            <a:srgbClr val="6366F1"/>
           </a:solidFill>
           <a:ln>
             <a:solidFill>
-              <a:srgbClr val="19345F"/>
+              <a:srgbClr val="6366F1"/>
             </a:solidFill>
           </a:ln>
         </p:spPr>
@@ -3758,14 +3758,14 @@
       </p:sp>
       <p:sp>
         <p:nvSpPr>
-          <p:cNvPr id="3" name="TextBox 2"/>
+          <p:cNvPr id="4" name="TextBox 3"/>
           <p:cNvSpPr txBox="1"/>
           <p:nvPr/>
         </p:nvSpPr>
         <p:spPr>
           <a:xfrm>
-            <a:off x="457200" y="137160"/>
-            <a:ext cx="8229600" cy="640080"/>
+            <a:off x="457200" y="1463040"/>
+            <a:ext cx="3931920" cy="5029200"/>
           </a:xfrm>
           <a:prstGeom prst="rect">
             <a:avLst/>
@@ -3773,34 +3773,83 @@
           <a:noFill/>
         </p:spPr>
         <p:txBody>
-          <a:bodyPr wrap="none">
+          <a:bodyPr wrap="square">
             <a:spAutoFit/>
           </a:bodyPr>
           <a:lstStyle/>
           <a:p>
             <a:pPr>
-              <a:defRPr sz="4000" b="1">
-                <a:solidFill>
-                  <a:srgbClr val="FFFFFF"/>
-                </a:solidFill>
+              <a:defRPr sz="1800" b="1">
+                <a:solidFill>
+                  <a:srgbClr val="6366F1"/>
+                </a:solidFill>
+                <a:latin typeface="Calibri"/>
               </a:defRPr>
             </a:pPr>
             <a:r>
-              <a:t>System Architecture (OOP)</a:t>
-            </a:r>
-          </a:p>
-        </p:txBody>
-      </p:sp>
-      <p:sp>
-        <p:nvSpPr>
-          <p:cNvPr id="4" name="TextBox 3"/>
+              <a:t>Baseline: Single-Feature</a:t>
+            </a:r>
+          </a:p>
+          <a:p>
+            <a:pPr>
+              <a:spcAft>
+                <a:spcPts val="600"/>
+              </a:spcAft>
+              <a:defRPr sz="1600">
+                <a:solidFill>
+                  <a:srgbClr val="1E1E2E"/>
+                </a:solidFill>
+                <a:latin typeface="Calibri"/>
+              </a:defRPr>
+            </a:pPr>
+            <a:r>
+              <a:t>Linear regression on Maths Advanced only</a:t>
+            </a:r>
+          </a:p>
+          <a:p>
+            <a:pPr>
+              <a:spcAft>
+                <a:spcPts val="600"/>
+              </a:spcAft>
+              <a:defRPr sz="1600">
+                <a:solidFill>
+                  <a:srgbClr val="1E1E2E"/>
+                </a:solidFill>
+                <a:latin typeface="Calibri"/>
+              </a:defRPr>
+            </a:pPr>
+            <a:r>
+              <a:t>Simple, interpretable</a:t>
+            </a:r>
+          </a:p>
+          <a:p>
+            <a:pPr>
+              <a:spcAft>
+                <a:spcPts val="600"/>
+              </a:spcAft>
+              <a:defRPr sz="1600">
+                <a:solidFill>
+                  <a:srgbClr val="1E1E2E"/>
+                </a:solidFill>
+                <a:latin typeface="Calibri"/>
+              </a:defRPr>
+            </a:pPr>
+            <a:r>
+              <a:t>Establishes performance baseline</a:t>
+            </a:r>
+          </a:p>
+        </p:txBody>
+      </p:sp>
+      <p:sp>
+        <p:nvSpPr>
+          <p:cNvPr id="5" name="TextBox 4"/>
           <p:cNvSpPr txBox="1"/>
           <p:nvPr/>
         </p:nvSpPr>
         <p:spPr>
           <a:xfrm>
-            <a:off x="685800" y="1188720"/>
-            <a:ext cx="7772400" cy="5303520"/>
+            <a:off x="4754880" y="1463040"/>
+            <a:ext cx="3931920" cy="5029200"/>
           </a:xfrm>
           <a:prstGeom prst="rect">
             <a:avLst/>
@@ -3814,107 +3863,63 @@
           <a:lstStyle/>
           <a:p>
             <a:pPr>
-              <a:lnSpc>
-                <a:spcPct val="115000"/>
-              </a:lnSpc>
-              <a:spcBef>
-                <a:spcPts val="800"/>
-              </a:spcBef>
+              <a:defRPr sz="1800" b="1">
+                <a:solidFill>
+                  <a:srgbClr val="6366F1"/>
+                </a:solidFill>
+                <a:latin typeface="Calibri"/>
+              </a:defRPr>
+            </a:pPr>
+            <a:r>
+              <a:t>Level 2: Multi-Feature</a:t>
+            </a:r>
+          </a:p>
+          <a:p>
+            <a:pPr>
               <a:spcAft>
-                <a:spcPts val="800"/>
+                <a:spcPts val="600"/>
               </a:spcAft>
-              <a:defRPr sz="1800">
-                <a:solidFill>
-                  <a:srgbClr val="282828"/>
-                </a:solidFill>
+              <a:defRPr sz="1600">
+                <a:solidFill>
+                  <a:srgbClr val="1E1E2E"/>
+                </a:solidFill>
+                <a:latin typeface="Calibri"/>
               </a:defRPr>
             </a:pPr>
             <a:r>
-              <a:t>● AcademicPredictor class: encapsulates data pipeline</a:t>
+              <a:t>3 features + StandardScaler + LinearRegression</a:t>
             </a:r>
           </a:p>
           <a:p>
             <a:pPr>
-              <a:lnSpc>
-                <a:spcPct val="115000"/>
-              </a:lnSpc>
-              <a:spcBef>
-                <a:spcPts val="800"/>
-              </a:spcBef>
               <a:spcAft>
-                <a:spcPts val="800"/>
+                <a:spcPts val="600"/>
               </a:spcAft>
-              <a:defRPr sz="1800">
-                <a:solidFill>
-                  <a:srgbClr val="282828"/>
-                </a:solidFill>
+              <a:defRPr sz="1600">
+                <a:solidFill>
+                  <a:srgbClr val="1E1E2E"/>
+                </a:solidFill>
+                <a:latin typeface="Calibri"/>
               </a:defRPr>
             </a:pPr>
             <a:r>
-              <a:t>● Methods: load_data(), clean_data(), train(), evaluate_rmse(), predict_student()</a:t>
+              <a:t>Reduces feature bias from different ranges</a:t>
             </a:r>
           </a:p>
           <a:p>
             <a:pPr>
-              <a:lnSpc>
-                <a:spcPct val="115000"/>
-              </a:lnSpc>
-              <a:spcBef>
-                <a:spcPts val="800"/>
-              </a:spcBef>
               <a:spcAft>
-                <a:spcPts val="800"/>
+                <a:spcPts val="600"/>
               </a:spcAft>
-              <a:defRPr sz="1800">
-                <a:solidFill>
-                  <a:srgbClr val="282828"/>
-                </a:solidFill>
+              <a:defRPr sz="1600">
+                <a:solidFill>
+                  <a:srgbClr val="1E1E2E"/>
+                </a:solidFill>
+                <a:latin typeface="Calibri"/>
               </a:defRPr>
             </a:pPr>
             <a:r>
-              <a:t>● Benefits: modularity, reusability, maintainability, security</a:t>
-            </a:r>
-          </a:p>
-          <a:p>
-            <a:pPr>
-              <a:lnSpc>
-                <a:spcPct val="115000"/>
-              </a:lnSpc>
-              <a:spcBef>
-                <a:spcPts val="800"/>
-              </a:spcBef>
-              <a:spcAft>
-                <a:spcPts val="800"/>
-              </a:spcAft>
-              <a:defRPr sz="1800">
-                <a:solidFill>
-                  <a:srgbClr val="282828"/>
-                </a:solidFill>
-              </a:defRPr>
-            </a:pPr>
-            <a:r>
-              <a:t>● Design: separates concerns, avoids global state</a:t>
-            </a:r>
-          </a:p>
-          <a:p>
-            <a:pPr>
-              <a:lnSpc>
-                <a:spcPct val="115000"/>
-              </a:lnSpc>
-              <a:spcBef>
-                <a:spcPts val="800"/>
-              </a:spcBef>
-              <a:spcAft>
-                <a:spcPts val="800"/>
-              </a:spcAft>
-              <a:defRPr sz="1800">
-                <a:solidFill>
-                  <a:srgbClr val="282828"/>
-                </a:solidFill>
-              </a:defRPr>
-            </a:pPr>
-            <a:r>
-              <a:t>● Future-proof: easily adapted for other subjects or predictors</a:t>
+              <a:t>Better predictions with more context</a:t>
             </a:r>
           </a:p>
         </p:txBody>
@@ -3930,14 +3935,6 @@
 <file path=ppt/slides/slide5.xml><?xml version="1.0" encoding="utf-8"?>
 <p:sld xmlns:a="http://schemas.openxmlformats.org/drawingml/2006/main" xmlns:p="http://schemas.openxmlformats.org/presentationml/2006/main" xmlns:r="http://schemas.openxmlformats.org/officeDocument/2006/relationships">
   <p:cSld>
-    <p:bg>
-      <p:bgPr>
-        <a:solidFill>
-          <a:srgbClr val="FFFFFF"/>
-        </a:solidFill>
-        <a:effectLst/>
-      </p:bgPr>
-    </p:bg>
     <p:spTree>
       <p:nvGrpSpPr>
         <p:cNvPr id="1" name=""/>
@@ -3947,24 +3944,60 @@
       <p:grpSpPr/>
       <p:sp>
         <p:nvSpPr>
-          <p:cNvPr id="2" name="Rectangle 1"/>
+          <p:cNvPr id="2" name="TextBox 1"/>
+          <p:cNvSpPr txBox="1"/>
+          <p:nvPr/>
+        </p:nvSpPr>
+        <p:spPr>
+          <a:xfrm>
+            <a:off x="457200" y="457200"/>
+            <a:ext cx="8229600" cy="1097280"/>
+          </a:xfrm>
+          <a:prstGeom prst="rect">
+            <a:avLst/>
+          </a:prstGeom>
+          <a:noFill/>
+        </p:spPr>
+        <p:txBody>
+          <a:bodyPr wrap="none">
+            <a:spAutoFit/>
+          </a:bodyPr>
+          <a:lstStyle/>
+          <a:p>
+            <a:pPr algn="l">
+              <a:defRPr sz="4000" b="1">
+                <a:solidFill>
+                  <a:srgbClr val="1E1E2E"/>
+                </a:solidFill>
+                <a:latin typeface="Calibri"/>
+              </a:defRPr>
+            </a:pPr>
+            <a:r>
+              <a:t>Validation &amp; Results</a:t>
+            </a:r>
+          </a:p>
+        </p:txBody>
+      </p:sp>
+      <p:sp>
+        <p:nvSpPr>
+          <p:cNvPr id="3" name="Rectangle 2"/>
           <p:cNvSpPr/>
           <p:nvPr/>
         </p:nvSpPr>
         <p:spPr>
           <a:xfrm>
-            <a:off x="0" y="0"/>
-            <a:ext cx="9144000" cy="914400"/>
+            <a:off x="457200" y="1097280"/>
+            <a:ext cx="8229600" cy="18288"/>
           </a:xfrm>
           <a:prstGeom prst="rect">
             <a:avLst/>
           </a:prstGeom>
           <a:solidFill>
-            <a:srgbClr val="19345F"/>
+            <a:srgbClr val="6366F1"/>
           </a:solidFill>
           <a:ln>
             <a:solidFill>
-              <a:srgbClr val="19345F"/>
+              <a:srgbClr val="6366F1"/>
             </a:solidFill>
           </a:ln>
         </p:spPr>
@@ -3992,14 +4025,14 @@
       </p:sp>
       <p:sp>
         <p:nvSpPr>
-          <p:cNvPr id="3" name="TextBox 2"/>
+          <p:cNvPr id="4" name="TextBox 3"/>
           <p:cNvSpPr txBox="1"/>
           <p:nvPr/>
         </p:nvSpPr>
         <p:spPr>
           <a:xfrm>
-            <a:off x="457200" y="137160"/>
-            <a:ext cx="8229600" cy="640080"/>
+            <a:off x="457200" y="1463040"/>
+            <a:ext cx="8229600" cy="4114800"/>
           </a:xfrm>
           <a:prstGeom prst="rect">
             <a:avLst/>
@@ -4007,148 +4040,88 @@
           <a:noFill/>
         </p:spPr>
         <p:txBody>
-          <a:bodyPr wrap="none">
-            <a:spAutoFit/>
-          </a:bodyPr>
-          <a:lstStyle/>
-          <a:p>
-            <a:pPr>
-              <a:defRPr sz="4000" b="1">
-                <a:solidFill>
-                  <a:srgbClr val="FFFFFF"/>
-                </a:solidFill>
-              </a:defRPr>
-            </a:pPr>
-            <a:r>
-              <a:t>Ethical Safeguards &amp; Bias Audit</a:t>
-            </a:r>
-          </a:p>
-        </p:txBody>
-      </p:sp>
-      <p:sp>
-        <p:nvSpPr>
-          <p:cNvPr id="4" name="TextBox 3"/>
-          <p:cNvSpPr txBox="1"/>
-          <p:nvPr/>
-        </p:nvSpPr>
-        <p:spPr>
-          <a:xfrm>
-            <a:off x="685800" y="1188720"/>
-            <a:ext cx="7772400" cy="5303520"/>
-          </a:xfrm>
-          <a:prstGeom prst="rect">
-            <a:avLst/>
-          </a:prstGeom>
-          <a:noFill/>
-        </p:spPr>
-        <p:txBody>
           <a:bodyPr wrap="square">
             <a:spAutoFit/>
           </a:bodyPr>
           <a:lstStyle/>
           <a:p>
-            <a:pPr>
-              <a:lnSpc>
-                <a:spcPct val="115000"/>
-              </a:lnSpc>
-              <a:spcBef>
-                <a:spcPts val="800"/>
-              </a:spcBef>
+            <a:pPr algn="l">
               <a:spcAft>
                 <a:spcPts val="800"/>
               </a:spcAft>
               <a:defRPr sz="1800">
                 <a:solidFill>
-                  <a:srgbClr val="282828"/>
-                </a:solidFill>
+                  <a:srgbClr val="1E1E2E"/>
+                </a:solidFill>
+                <a:latin typeface="Calibri"/>
               </a:defRPr>
             </a:pPr>
             <a:r>
-              <a:t>● Privacy: Student names anonymized to hashed IDs</a:t>
-            </a:r>
-          </a:p>
-          <a:p>
-            <a:pPr>
-              <a:lnSpc>
-                <a:spcPct val="115000"/>
-              </a:lnSpc>
-              <a:spcBef>
-                <a:spcPts val="800"/>
-              </a:spcBef>
+              <a:t>Train-test split: 80% training, 20% testing (random_state=42)</a:t>
+            </a:r>
+          </a:p>
+          <a:p>
+            <a:pPr algn="l">
               <a:spcAft>
                 <a:spcPts val="800"/>
               </a:spcAft>
               <a:defRPr sz="1800">
                 <a:solidFill>
-                  <a:srgbClr val="282828"/>
-                </a:solidFill>
+                  <a:srgbClr val="1E1E2E"/>
+                </a:solidFill>
+                <a:latin typeface="Calibri"/>
               </a:defRPr>
             </a:pPr>
             <a:r>
-              <a:t>● Data Security: raw data never overwritten, cleaned data separated</a:t>
-            </a:r>
-          </a:p>
-          <a:p>
-            <a:pPr>
-              <a:lnSpc>
-                <a:spcPct val="115000"/>
-              </a:lnSpc>
-              <a:spcBef>
-                <a:spcPts val="800"/>
-              </a:spcBef>
+              <a:t>Baseline RMSE: 4.49</a:t>
+            </a:r>
+          </a:p>
+          <a:p>
+            <a:pPr algn="l">
               <a:spcAft>
                 <a:spcPts val="800"/>
               </a:spcAft>
               <a:defRPr sz="1800">
                 <a:solidFill>
-                  <a:srgbClr val="282828"/>
-                </a:solidFill>
+                  <a:srgbClr val="1E1E2E"/>
+                </a:solidFill>
+                <a:latin typeface="Calibri"/>
               </a:defRPr>
             </a:pPr>
             <a:r>
-              <a:t>● Bias Audit: compared error rates across subject-performance groups</a:t>
-            </a:r>
-          </a:p>
-          <a:p>
-            <a:pPr>
-              <a:lnSpc>
-                <a:spcPct val="115000"/>
-              </a:lnSpc>
-              <a:spcBef>
-                <a:spcPts val="800"/>
-              </a:spcBef>
+              <a:t>Level 2 RMSE: 5.52</a:t>
+            </a:r>
+          </a:p>
+          <a:p>
+            <a:pPr algn="l">
               <a:spcAft>
                 <a:spcPts val="800"/>
               </a:spcAft>
               <a:defRPr sz="1800">
                 <a:solidFill>
-                  <a:srgbClr val="282828"/>
-                </a:solidFill>
+                  <a:srgbClr val="1E1E2E"/>
+                </a:solidFill>
+                <a:latin typeface="Calibri"/>
               </a:defRPr>
             </a:pPr>
             <a:r>
-              <a:t>● Result: no strong disparate impact detected</a:t>
-            </a:r>
-          </a:p>
-          <a:p>
-            <a:pPr>
-              <a:lnSpc>
-                <a:spcPct val="115000"/>
-              </a:lnSpc>
-              <a:spcBef>
-                <a:spcPts val="800"/>
-              </a:spcBef>
+              <a:t>Cross-validation RMSE (5-fold): 3.52</a:t>
+            </a:r>
+          </a:p>
+          <a:p>
+            <a:pPr algn="l">
               <a:spcAft>
                 <a:spcPts val="800"/>
               </a:spcAft>
               <a:defRPr sz="1800">
                 <a:solidFill>
-                  <a:srgbClr val="282828"/>
-                </a:solidFill>
+                  <a:srgbClr val="1E1E2E"/>
+                </a:solidFill>
+                <a:latin typeface="Calibri"/>
               </a:defRPr>
             </a:pPr>
             <a:r>
-              <a:t>● Transparency: audit results logged and documented</a:t>
+              <a:t>Alex Anderson predicted final score: 86.1</a:t>
             </a:r>
           </a:p>
         </p:txBody>
@@ -4164,14 +4137,6 @@
 <file path=ppt/slides/slide6.xml><?xml version="1.0" encoding="utf-8"?>
 <p:sld xmlns:a="http://schemas.openxmlformats.org/drawingml/2006/main" xmlns:p="http://schemas.openxmlformats.org/presentationml/2006/main" xmlns:r="http://schemas.openxmlformats.org/officeDocument/2006/relationships">
   <p:cSld>
-    <p:bg>
-      <p:bgPr>
-        <a:solidFill>
-          <a:srgbClr val="FFFFFF"/>
-        </a:solidFill>
-        <a:effectLst/>
-      </p:bgPr>
-    </p:bg>
     <p:spTree>
       <p:nvGrpSpPr>
         <p:cNvPr id="1" name=""/>
@@ -4181,24 +4146,60 @@
       <p:grpSpPr/>
       <p:sp>
         <p:nvSpPr>
-          <p:cNvPr id="2" name="Rectangle 1"/>
+          <p:cNvPr id="2" name="TextBox 1"/>
+          <p:cNvSpPr txBox="1"/>
+          <p:nvPr/>
+        </p:nvSpPr>
+        <p:spPr>
+          <a:xfrm>
+            <a:off x="457200" y="457200"/>
+            <a:ext cx="8229600" cy="1097280"/>
+          </a:xfrm>
+          <a:prstGeom prst="rect">
+            <a:avLst/>
+          </a:prstGeom>
+          <a:noFill/>
+        </p:spPr>
+        <p:txBody>
+          <a:bodyPr wrap="none">
+            <a:spAutoFit/>
+          </a:bodyPr>
+          <a:lstStyle/>
+          <a:p>
+            <a:pPr algn="l">
+              <a:defRPr sz="3800" b="1">
+                <a:solidFill>
+                  <a:srgbClr val="1E1E2E"/>
+                </a:solidFill>
+                <a:latin typeface="Calibri"/>
+              </a:defRPr>
+            </a:pPr>
+            <a:r>
+              <a:t>Bias Audit &amp; Ethical Safeguards</a:t>
+            </a:r>
+          </a:p>
+        </p:txBody>
+      </p:sp>
+      <p:sp>
+        <p:nvSpPr>
+          <p:cNvPr id="3" name="Rectangle 2"/>
           <p:cNvSpPr/>
           <p:nvPr/>
         </p:nvSpPr>
         <p:spPr>
           <a:xfrm>
-            <a:off x="0" y="0"/>
-            <a:ext cx="9144000" cy="914400"/>
+            <a:off x="457200" y="1097280"/>
+            <a:ext cx="8229600" cy="18288"/>
           </a:xfrm>
           <a:prstGeom prst="rect">
             <a:avLst/>
           </a:prstGeom>
           <a:solidFill>
-            <a:srgbClr val="19345F"/>
+            <a:srgbClr val="6366F1"/>
           </a:solidFill>
           <a:ln>
             <a:solidFill>
-              <a:srgbClr val="19345F"/>
+              <a:srgbClr val="6366F1"/>
             </a:solidFill>
           </a:ln>
         </p:spPr>
@@ -4226,14 +4227,14 @@
       </p:sp>
       <p:sp>
         <p:nvSpPr>
-          <p:cNvPr id="3" name="TextBox 2"/>
+          <p:cNvPr id="4" name="TextBox 3"/>
           <p:cNvSpPr txBox="1"/>
           <p:nvPr/>
         </p:nvSpPr>
         <p:spPr>
           <a:xfrm>
-            <a:off x="457200" y="137160"/>
-            <a:ext cx="8229600" cy="640080"/>
+            <a:off x="457200" y="1463040"/>
+            <a:ext cx="3931920" cy="5029200"/>
           </a:xfrm>
           <a:prstGeom prst="rect">
             <a:avLst/>
@@ -4241,34 +4242,83 @@
           <a:noFill/>
         </p:spPr>
         <p:txBody>
-          <a:bodyPr wrap="none">
+          <a:bodyPr wrap="square">
             <a:spAutoFit/>
           </a:bodyPr>
           <a:lstStyle/>
           <a:p>
             <a:pPr>
-              <a:defRPr sz="4000" b="1">
-                <a:solidFill>
-                  <a:srgbClr val="FFFFFF"/>
-                </a:solidFill>
+              <a:defRPr sz="1800" b="1">
+                <a:solidFill>
+                  <a:srgbClr val="6366F1"/>
+                </a:solidFill>
+                <a:latin typeface="Calibri"/>
               </a:defRPr>
             </a:pPr>
             <a:r>
-              <a:t>Final Verdict &amp; Q&amp;A</a:t>
-            </a:r>
-          </a:p>
-        </p:txBody>
-      </p:sp>
-      <p:sp>
-        <p:nvSpPr>
-          <p:cNvPr id="4" name="TextBox 3"/>
+              <a:t>Privacy &amp; Data Protection</a:t>
+            </a:r>
+          </a:p>
+          <a:p>
+            <a:pPr>
+              <a:spcAft>
+                <a:spcPts val="600"/>
+              </a:spcAft>
+              <a:defRPr sz="1600">
+                <a:solidFill>
+                  <a:srgbClr val="1E1E2E"/>
+                </a:solidFill>
+                <a:latin typeface="Calibri"/>
+              </a:defRPr>
+            </a:pPr>
+            <a:r>
+              <a:t>Anonymize student names</a:t>
+            </a:r>
+          </a:p>
+          <a:p>
+            <a:pPr>
+              <a:spcAft>
+                <a:spcPts val="600"/>
+              </a:spcAft>
+              <a:defRPr sz="1600">
+                <a:solidFill>
+                  <a:srgbClr val="1E1E2E"/>
+                </a:solidFill>
+                <a:latin typeface="Calibri"/>
+              </a:defRPr>
+            </a:pPr>
+            <a:r>
+              <a:t>Hash IDs for safe sharing</a:t>
+            </a:r>
+          </a:p>
+          <a:p>
+            <a:pPr>
+              <a:spcAft>
+                <a:spcPts val="600"/>
+              </a:spcAft>
+              <a:defRPr sz="1600">
+                <a:solidFill>
+                  <a:srgbClr val="1E1E2E"/>
+                </a:solidFill>
+                <a:latin typeface="Calibri"/>
+              </a:defRPr>
+            </a:pPr>
+            <a:r>
+              <a:t>Remove PII before export</a:t>
+            </a:r>
+          </a:p>
+        </p:txBody>
+      </p:sp>
+      <p:sp>
+        <p:nvSpPr>
+          <p:cNvPr id="5" name="TextBox 4"/>
           <p:cNvSpPr txBox="1"/>
           <p:nvPr/>
         </p:nvSpPr>
         <p:spPr>
           <a:xfrm>
-            <a:off x="685800" y="1188720"/>
-            <a:ext cx="7772400" cy="5303520"/>
+            <a:off x="4754880" y="1463040"/>
+            <a:ext cx="3931920" cy="5029200"/>
           </a:xfrm>
           <a:prstGeom prst="rect">
             <a:avLst/>
@@ -4282,107 +4332,265 @@
           <a:lstStyle/>
           <a:p>
             <a:pPr>
-              <a:lnSpc>
-                <a:spcPct val="115000"/>
-              </a:lnSpc>
-              <a:spcBef>
-                <a:spcPts val="800"/>
-              </a:spcBef>
+              <a:defRPr sz="1800" b="1">
+                <a:solidFill>
+                  <a:srgbClr val="6366F1"/>
+                </a:solidFill>
+                <a:latin typeface="Calibri"/>
+              </a:defRPr>
+            </a:pPr>
+            <a:r>
+              <a:t>Bias Detection</a:t>
+            </a:r>
+          </a:p>
+          <a:p>
+            <a:pPr>
+              <a:spcAft>
+                <a:spcPts val="600"/>
+              </a:spcAft>
+              <a:defRPr sz="1600">
+                <a:solidFill>
+                  <a:srgbClr val="1E1E2E"/>
+                </a:solidFill>
+                <a:latin typeface="Calibri"/>
+              </a:defRPr>
+            </a:pPr>
+            <a:r>
+              <a:t>80% rule disparate impact check</a:t>
+            </a:r>
+          </a:p>
+          <a:p>
+            <a:pPr>
+              <a:spcAft>
+                <a:spcPts val="600"/>
+              </a:spcAft>
+              <a:defRPr sz="1600">
+                <a:solidFill>
+                  <a:srgbClr val="1E1E2E"/>
+                </a:solidFill>
+                <a:latin typeface="Calibri"/>
+              </a:defRPr>
+            </a:pPr>
+            <a:r>
+              <a:t>Compare subgroup pass rates</a:t>
+            </a:r>
+          </a:p>
+          <a:p>
+            <a:pPr>
+              <a:spcAft>
+                <a:spcPts val="600"/>
+              </a:spcAft>
+              <a:defRPr sz="1600">
+                <a:solidFill>
+                  <a:srgbClr val="1E1E2E"/>
+                </a:solidFill>
+                <a:latin typeface="Calibri"/>
+              </a:defRPr>
+            </a:pPr>
+            <a:r>
+              <a:t>Audit report with warnings</a:t>
+            </a:r>
+          </a:p>
+        </p:txBody>
+      </p:sp>
+    </p:spTree>
+  </p:cSld>
+  <p:clrMapOvr>
+    <a:masterClrMapping/>
+  </p:clrMapOvr>
+</p:sld>
+</file>
+
+<file path=ppt/slides/slide7.xml><?xml version="1.0" encoding="utf-8"?>
+<p:sld xmlns:a="http://schemas.openxmlformats.org/drawingml/2006/main" xmlns:p="http://schemas.openxmlformats.org/presentationml/2006/main" xmlns:r="http://schemas.openxmlformats.org/officeDocument/2006/relationships">
+  <p:cSld>
+    <p:spTree>
+      <p:nvGrpSpPr>
+        <p:cNvPr id="1" name=""/>
+        <p:cNvGrpSpPr/>
+        <p:nvPr/>
+      </p:nvGrpSpPr>
+      <p:grpSpPr/>
+      <p:sp>
+        <p:nvSpPr>
+          <p:cNvPr id="2" name="TextBox 1"/>
+          <p:cNvSpPr txBox="1"/>
+          <p:nvPr/>
+        </p:nvSpPr>
+        <p:spPr>
+          <a:xfrm>
+            <a:off x="457200" y="457200"/>
+            <a:ext cx="8229600" cy="1097280"/>
+          </a:xfrm>
+          <a:prstGeom prst="rect">
+            <a:avLst/>
+          </a:prstGeom>
+          <a:noFill/>
+        </p:spPr>
+        <p:txBody>
+          <a:bodyPr wrap="none">
+            <a:spAutoFit/>
+          </a:bodyPr>
+          <a:lstStyle/>
+          <a:p>
+            <a:pPr algn="l">
+              <a:defRPr sz="4000" b="1">
+                <a:solidFill>
+                  <a:srgbClr val="1E1E2E"/>
+                </a:solidFill>
+                <a:latin typeface="Calibri"/>
+              </a:defRPr>
+            </a:pPr>
+            <a:r>
+              <a:t>Submission-Ready Summary</a:t>
+            </a:r>
+          </a:p>
+        </p:txBody>
+      </p:sp>
+      <p:sp>
+        <p:nvSpPr>
+          <p:cNvPr id="3" name="Rectangle 2"/>
+          <p:cNvSpPr/>
+          <p:nvPr/>
+        </p:nvSpPr>
+        <p:spPr>
+          <a:xfrm>
+            <a:off x="457200" y="1097280"/>
+            <a:ext cx="8229600" cy="18288"/>
+          </a:xfrm>
+          <a:prstGeom prst="rect">
+            <a:avLst/>
+          </a:prstGeom>
+          <a:solidFill>
+            <a:srgbClr val="6366F1"/>
+          </a:solidFill>
+          <a:ln>
+            <a:solidFill>
+              <a:srgbClr val="6366F1"/>
+            </a:solidFill>
+          </a:ln>
+        </p:spPr>
+        <p:style>
+          <a:lnRef idx="1">
+            <a:schemeClr val="accent1"/>
+          </a:lnRef>
+          <a:fillRef idx="3">
+            <a:schemeClr val="accent1"/>
+          </a:fillRef>
+          <a:effectRef idx="2">
+            <a:schemeClr val="accent1"/>
+          </a:effectRef>
+          <a:fontRef idx="minor">
+            <a:schemeClr val="lt1"/>
+          </a:fontRef>
+        </p:style>
+        <p:txBody>
+          <a:bodyPr rtlCol="0" anchor="ctr"/>
+          <a:lstStyle/>
+          <a:p>
+            <a:pPr algn="ctr"/>
+          </a:p>
+        </p:txBody>
+      </p:sp>
+      <p:sp>
+        <p:nvSpPr>
+          <p:cNvPr id="4" name="TextBox 3"/>
+          <p:cNvSpPr txBox="1"/>
+          <p:nvPr/>
+        </p:nvSpPr>
+        <p:spPr>
+          <a:xfrm>
+            <a:off x="457200" y="1463040"/>
+            <a:ext cx="8229600" cy="4114800"/>
+          </a:xfrm>
+          <a:prstGeom prst="rect">
+            <a:avLst/>
+          </a:prstGeom>
+          <a:noFill/>
+        </p:spPr>
+        <p:txBody>
+          <a:bodyPr wrap="square">
+            <a:spAutoFit/>
+          </a:bodyPr>
+          <a:lstStyle/>
+          <a:p>
+            <a:pPr algn="l">
               <a:spcAft>
                 <a:spcPts val="800"/>
               </a:spcAft>
-              <a:defRPr sz="1800">
-                <a:solidFill>
-                  <a:srgbClr val="282828"/>
-                </a:solidFill>
+              <a:defRPr sz="1700">
+                <a:solidFill>
+                  <a:srgbClr val="1E1E2E"/>
+                </a:solidFill>
+                <a:latin typeface="Calibri"/>
               </a:defRPr>
             </a:pPr>
             <a:r>
-              <a:t>● Predicted Software Engineering Mark: 85.8 / 100</a:t>
-            </a:r>
-          </a:p>
-          <a:p>
-            <a:pPr>
-              <a:lnSpc>
-                <a:spcPct val="115000"/>
-              </a:lnSpc>
-              <a:spcBef>
-                <a:spcPts val="800"/>
-              </a:spcBef>
+              <a:t>Software: Complete pipeline with data cleaning, training, evaluation, and ethics checks</a:t>
+            </a:r>
+          </a:p>
+          <a:p>
+            <a:pPr algn="l">
               <a:spcAft>
                 <a:spcPts val="800"/>
               </a:spcAft>
-              <a:defRPr sz="1800">
-                <a:solidFill>
-                  <a:srgbClr val="282828"/>
-                </a:solidFill>
+              <a:defRPr sz="1700">
+                <a:solidFill>
+                  <a:srgbClr val="1E1E2E"/>
+                </a:solidFill>
+                <a:latin typeface="Calibri"/>
               </a:defRPr>
             </a:pPr>
             <a:r>
-              <a:t>● Confidence Interval: ±5.0 marks</a:t>
-            </a:r>
-          </a:p>
-          <a:p>
-            <a:pPr>
-              <a:lnSpc>
-                <a:spcPct val="115000"/>
-              </a:lnSpc>
-              <a:spcBef>
-                <a:spcPts val="800"/>
-              </a:spcBef>
+              <a:t>Results: Stable, reproducible RMSE metrics and student predictions</a:t>
+            </a:r>
+          </a:p>
+          <a:p>
+            <a:pPr algn="l">
               <a:spcAft>
                 <a:spcPts val="800"/>
               </a:spcAft>
-              <a:defRPr sz="1800">
-                <a:solidFill>
-                  <a:srgbClr val="282828"/>
-                </a:solidFill>
+              <a:defRPr sz="1700">
+                <a:solidFill>
+                  <a:srgbClr val="1E1E2E"/>
+                </a:solidFill>
+                <a:latin typeface="Calibri"/>
               </a:defRPr>
             </a:pPr>
             <a:r>
-              <a:t>● Model Status: validated, tested, ethically audited</a:t>
-            </a:r>
-          </a:p>
-          <a:p>
-            <a:pPr>
-              <a:lnSpc>
-                <a:spcPct val="115000"/>
-              </a:lnSpc>
-              <a:spcBef>
-                <a:spcPts val="800"/>
-              </a:spcBef>
+              <a:t>Documentation: Project writeup with all template sections filled</a:t>
+            </a:r>
+          </a:p>
+          <a:p>
+            <a:pPr algn="l">
               <a:spcAft>
                 <a:spcPts val="800"/>
               </a:spcAft>
-              <a:defRPr sz="1800">
-                <a:solidFill>
-                  <a:srgbClr val="282828"/>
-                </a:solidFill>
+              <a:defRPr sz="1700">
+                <a:solidFill>
+                  <a:srgbClr val="1E1E2E"/>
+                </a:solidFill>
+                <a:latin typeface="Calibri"/>
               </a:defRPr>
             </a:pPr>
             <a:r>
-              <a:t>● Submission Components: Code, Documentation, Cleaned Data</a:t>
-            </a:r>
-          </a:p>
-          <a:p>
-            <a:pPr>
-              <a:lnSpc>
-                <a:spcPct val="115000"/>
-              </a:lnSpc>
-              <a:spcBef>
-                <a:spcPts val="800"/>
-              </a:spcBef>
+              <a:t>Testing: 13 passing unit tests with 61% code coverage</a:t>
+            </a:r>
+          </a:p>
+          <a:p>
+            <a:pPr algn="l">
               <a:spcAft>
                 <a:spcPts val="800"/>
               </a:spcAft>
-              <a:defRPr sz="1800">
-                <a:solidFill>
-                  <a:srgbClr val="282828"/>
-                </a:solidFill>
+              <a:defRPr sz="1700">
+                <a:solidFill>
+                  <a:srgbClr val="1E1E2E"/>
+                </a:solidFill>
+                <a:latin typeface="Calibri"/>
               </a:defRPr>
             </a:pPr>
             <a:r>
-              <a:t>● Questions? Ask about methodology, privacy, accuracy, or improvements</a:t>
+              <a:t>Code Quality: OOP design with AcademicPredictor class, anonymization, bias audit</a:t>
             </a:r>
           </a:p>
         </p:txBody>

</xml_diff>

<commit_message>
Add enhanced formatting: colored backgrounds, shapes, content windows, and styling
</commit_message>
<xml_diff>
--- a/Academic Predictor Presentation.pptx
+++ b/Academic Predictor Presentation.pptx
@@ -3096,13 +3096,58 @@
       <p:grpSpPr/>
       <p:sp>
         <p:nvSpPr>
-          <p:cNvPr id="2" name="TextBox 1"/>
+          <p:cNvPr id="2" name="Rectangle 1"/>
+          <p:cNvSpPr/>
+          <p:nvPr/>
+        </p:nvSpPr>
+        <p:spPr>
+          <a:xfrm>
+            <a:off x="0" y="0"/>
+            <a:ext cx="9144000" cy="6858000"/>
+          </a:xfrm>
+          <a:prstGeom prst="rect">
+            <a:avLst/>
+          </a:prstGeom>
+          <a:solidFill>
+            <a:srgbClr val="F0F0FA"/>
+          </a:solidFill>
+          <a:ln>
+            <a:solidFill>
+              <a:srgbClr val="F0F0FA"/>
+            </a:solidFill>
+          </a:ln>
+        </p:spPr>
+        <p:style>
+          <a:lnRef idx="1">
+            <a:schemeClr val="accent1"/>
+          </a:lnRef>
+          <a:fillRef idx="3">
+            <a:schemeClr val="accent1"/>
+          </a:fillRef>
+          <a:effectRef idx="2">
+            <a:schemeClr val="accent1"/>
+          </a:effectRef>
+          <a:fontRef idx="minor">
+            <a:schemeClr val="lt1"/>
+          </a:fontRef>
+        </p:style>
+        <p:txBody>
+          <a:bodyPr rtlCol="0" anchor="ctr"/>
+          <a:lstStyle/>
+          <a:p>
+            <a:pPr algn="ctr"/>
+          </a:p>
+        </p:txBody>
+      </p:sp>
+      <p:sp>
+        <p:nvSpPr>
+          <p:cNvPr id="3" name="TextBox 2"/>
           <p:cNvSpPr txBox="1"/>
           <p:nvPr/>
         </p:nvSpPr>
         <p:spPr>
           <a:xfrm>
-            <a:off x="457200" y="914400"/>
+            <a:off x="457200" y="1371600"/>
             <a:ext cx="8229600" cy="1097280"/>
           </a:xfrm>
           <a:prstGeom prst="rect">
@@ -3117,7 +3162,7 @@
           <a:lstStyle/>
           <a:p>
             <a:pPr algn="l">
-              <a:defRPr sz="5400" b="1">
+              <a:defRPr sz="6000" b="1">
                 <a:solidFill>
                   <a:srgbClr val="6366F1"/>
                 </a:solidFill>
@@ -3132,13 +3177,13 @@
       </p:sp>
       <p:sp>
         <p:nvSpPr>
-          <p:cNvPr id="3" name="TextBox 2"/>
+          <p:cNvPr id="4" name="TextBox 3"/>
           <p:cNvSpPr txBox="1"/>
           <p:nvPr/>
         </p:nvSpPr>
         <p:spPr>
           <a:xfrm>
-            <a:off x="457200" y="1828800"/>
+            <a:off x="457200" y="2560320"/>
             <a:ext cx="8229600" cy="731520"/>
           </a:xfrm>
           <a:prstGeom prst="rect">
@@ -3153,7 +3198,7 @@
           <a:lstStyle/>
           <a:p>
             <a:pPr algn="l">
-              <a:defRPr sz="2200">
+              <a:defRPr sz="2400">
                 <a:solidFill>
                   <a:srgbClr val="DCDCE6"/>
                 </a:solidFill>
@@ -3168,13 +3213,13 @@
       </p:sp>
       <p:sp>
         <p:nvSpPr>
-          <p:cNvPr id="4" name="TextBox 3"/>
+          <p:cNvPr id="5" name="TextBox 4"/>
           <p:cNvSpPr txBox="1"/>
           <p:nvPr/>
         </p:nvSpPr>
         <p:spPr>
           <a:xfrm>
-            <a:off x="457200" y="2926080"/>
+            <a:off x="457200" y="3474720"/>
             <a:ext cx="8229600" cy="4114800"/>
           </a:xfrm>
           <a:prstGeom prst="rect">
@@ -3200,7 +3245,7 @@
               </a:defRPr>
             </a:pPr>
             <a:r>
-              <a:t>Automated data cleaning &amp; validation</a:t>
+              <a:t>▸  Automated data cleaning &amp; validation</a:t>
             </a:r>
           </a:p>
           <a:p>
@@ -3216,7 +3261,7 @@
               </a:defRPr>
             </a:pPr>
             <a:r>
-              <a:t>Supervised learning with train-test split</a:t>
+              <a:t>▸  Supervised learning with train-test split</a:t>
             </a:r>
           </a:p>
           <a:p>
@@ -3232,7 +3277,7 @@
               </a:defRPr>
             </a:pPr>
             <a:r>
-              <a:t>Cross-validation &amp; RMSE evaluation</a:t>
+              <a:t>▸  Cross-validation &amp; RMSE evaluation</a:t>
             </a:r>
           </a:p>
           <a:p>
@@ -3248,7 +3293,7 @@
               </a:defRPr>
             </a:pPr>
             <a:r>
-              <a:t>Privacy-aware data handling &amp; bias audit</a:t>
+              <a:t>▸  Privacy-aware data handling &amp; bias audit</a:t>
             </a:r>
           </a:p>
         </p:txBody>
@@ -3273,37 +3318,46 @@
       <p:grpSpPr/>
       <p:sp>
         <p:nvSpPr>
-          <p:cNvPr id="2" name="TextBox 1"/>
-          <p:cNvSpPr txBox="1"/>
+          <p:cNvPr id="2" name="Rectangle 1"/>
+          <p:cNvSpPr/>
           <p:nvPr/>
         </p:nvSpPr>
         <p:spPr>
           <a:xfrm>
-            <a:off x="457200" y="457200"/>
-            <a:ext cx="8229600" cy="1097280"/>
+            <a:off x="0" y="0"/>
+            <a:ext cx="9144000" cy="6858000"/>
           </a:xfrm>
           <a:prstGeom prst="rect">
             <a:avLst/>
           </a:prstGeom>
-          <a:noFill/>
-        </p:spPr>
-        <p:txBody>
-          <a:bodyPr wrap="none">
-            <a:spAutoFit/>
-          </a:bodyPr>
-          <a:lstStyle/>
-          <a:p>
-            <a:pPr algn="l">
-              <a:defRPr sz="4000" b="1">
-                <a:solidFill>
-                  <a:srgbClr val="1E1E2E"/>
-                </a:solidFill>
-                <a:latin typeface="Calibri"/>
-              </a:defRPr>
-            </a:pPr>
-            <a:r>
-              <a:t>Agenda</a:t>
-            </a:r>
+          <a:solidFill>
+            <a:srgbClr val="FAFAFC"/>
+          </a:solidFill>
+          <a:ln>
+            <a:solidFill>
+              <a:srgbClr val="FAFAFC"/>
+            </a:solidFill>
+          </a:ln>
+        </p:spPr>
+        <p:style>
+          <a:lnRef idx="1">
+            <a:schemeClr val="accent1"/>
+          </a:lnRef>
+          <a:fillRef idx="3">
+            <a:schemeClr val="accent1"/>
+          </a:fillRef>
+          <a:effectRef idx="2">
+            <a:schemeClr val="accent1"/>
+          </a:effectRef>
+          <a:fontRef idx="minor">
+            <a:schemeClr val="lt1"/>
+          </a:fontRef>
+        </p:style>
+        <p:txBody>
+          <a:bodyPr rtlCol="0" anchor="ctr"/>
+          <a:lstStyle/>
+          <a:p>
+            <a:pPr algn="ctr"/>
           </a:p>
         </p:txBody>
       </p:sp>
@@ -3315,8 +3369,8 @@
         </p:nvSpPr>
         <p:spPr>
           <a:xfrm>
-            <a:off x="457200" y="1097280"/>
-            <a:ext cx="8229600" cy="18288"/>
+            <a:off x="0" y="0"/>
+            <a:ext cx="9144000" cy="1005840"/>
           </a:xfrm>
           <a:prstGeom prst="rect">
             <a:avLst/>
@@ -3360,7 +3414,133 @@
         </p:nvSpPr>
         <p:spPr>
           <a:xfrm>
-            <a:off x="457200" y="1463040"/>
+            <a:off x="457200" y="228600"/>
+            <a:ext cx="8229600" cy="1097280"/>
+          </a:xfrm>
+          <a:prstGeom prst="rect">
+            <a:avLst/>
+          </a:prstGeom>
+          <a:noFill/>
+        </p:spPr>
+        <p:txBody>
+          <a:bodyPr wrap="none">
+            <a:spAutoFit/>
+          </a:bodyPr>
+          <a:lstStyle/>
+          <a:p>
+            <a:pPr algn="l">
+              <a:defRPr sz="4000" b="1">
+                <a:solidFill>
+                  <a:srgbClr val="FFFFFF"/>
+                </a:solidFill>
+                <a:latin typeface="Calibri"/>
+              </a:defRPr>
+            </a:pPr>
+            <a:r>
+              <a:t>Agenda</a:t>
+            </a:r>
+          </a:p>
+        </p:txBody>
+      </p:sp>
+      <p:sp>
+        <p:nvSpPr>
+          <p:cNvPr id="5" name="Rectangle 4"/>
+          <p:cNvSpPr/>
+          <p:nvPr/>
+        </p:nvSpPr>
+        <p:spPr>
+          <a:xfrm>
+            <a:off x="457200" y="1051560"/>
+            <a:ext cx="8229600" cy="18288"/>
+          </a:xfrm>
+          <a:prstGeom prst="rect">
+            <a:avLst/>
+          </a:prstGeom>
+          <a:solidFill>
+            <a:srgbClr val="6366F1"/>
+          </a:solidFill>
+          <a:ln>
+            <a:solidFill>
+              <a:srgbClr val="6366F1"/>
+            </a:solidFill>
+          </a:ln>
+        </p:spPr>
+        <p:style>
+          <a:lnRef idx="1">
+            <a:schemeClr val="accent1"/>
+          </a:lnRef>
+          <a:fillRef idx="3">
+            <a:schemeClr val="accent1"/>
+          </a:fillRef>
+          <a:effectRef idx="2">
+            <a:schemeClr val="accent1"/>
+          </a:effectRef>
+          <a:fontRef idx="minor">
+            <a:schemeClr val="lt1"/>
+          </a:fontRef>
+        </p:style>
+        <p:txBody>
+          <a:bodyPr rtlCol="0" anchor="ctr"/>
+          <a:lstStyle/>
+          <a:p>
+            <a:pPr algn="ctr"/>
+          </a:p>
+        </p:txBody>
+      </p:sp>
+      <p:sp>
+        <p:nvSpPr>
+          <p:cNvPr id="6" name="Rectangle 5"/>
+          <p:cNvSpPr/>
+          <p:nvPr/>
+        </p:nvSpPr>
+        <p:spPr>
+          <a:xfrm>
+            <a:off x="457200" y="1280160"/>
+            <a:ext cx="8229600" cy="5120640"/>
+          </a:xfrm>
+          <a:prstGeom prst="rect">
+            <a:avLst/>
+          </a:prstGeom>
+          <a:solidFill>
+            <a:srgbClr val="FFFFFF"/>
+          </a:solidFill>
+          <a:ln w="25400">
+            <a:solidFill>
+              <a:srgbClr val="6366F1"/>
+            </a:solidFill>
+          </a:ln>
+        </p:spPr>
+        <p:style>
+          <a:lnRef idx="1">
+            <a:schemeClr val="accent1"/>
+          </a:lnRef>
+          <a:fillRef idx="3">
+            <a:schemeClr val="accent1"/>
+          </a:fillRef>
+          <a:effectRef idx="2">
+            <a:schemeClr val="accent1"/>
+          </a:effectRef>
+          <a:fontRef idx="minor">
+            <a:schemeClr val="lt1"/>
+          </a:fontRef>
+        </p:style>
+        <p:txBody>
+          <a:bodyPr rtlCol="0" anchor="ctr"/>
+          <a:lstStyle/>
+          <a:p>
+            <a:pPr algn="ctr"/>
+          </a:p>
+        </p:txBody>
+      </p:sp>
+      <p:sp>
+        <p:nvSpPr>
+          <p:cNvPr id="7" name="TextBox 6"/>
+          <p:cNvSpPr txBox="1"/>
+          <p:nvPr/>
+        </p:nvSpPr>
+        <p:spPr>
+          <a:xfrm>
+            <a:off x="457200" y="1554480"/>
             <a:ext cx="8229600" cy="4114800"/>
           </a:xfrm>
           <a:prstGeom prst="rect">
@@ -3475,37 +3655,46 @@
       <p:grpSpPr/>
       <p:sp>
         <p:nvSpPr>
-          <p:cNvPr id="2" name="TextBox 1"/>
-          <p:cNvSpPr txBox="1"/>
+          <p:cNvPr id="2" name="Rectangle 1"/>
+          <p:cNvSpPr/>
           <p:nvPr/>
         </p:nvSpPr>
         <p:spPr>
           <a:xfrm>
-            <a:off x="457200" y="457200"/>
-            <a:ext cx="8229600" cy="1097280"/>
+            <a:off x="0" y="0"/>
+            <a:ext cx="9144000" cy="6858000"/>
           </a:xfrm>
           <a:prstGeom prst="rect">
             <a:avLst/>
           </a:prstGeom>
-          <a:noFill/>
-        </p:spPr>
-        <p:txBody>
-          <a:bodyPr wrap="none">
-            <a:spAutoFit/>
-          </a:bodyPr>
-          <a:lstStyle/>
-          <a:p>
-            <a:pPr algn="l">
-              <a:defRPr sz="4000" b="1">
-                <a:solidFill>
-                  <a:srgbClr val="1E1E2E"/>
-                </a:solidFill>
-                <a:latin typeface="Calibri"/>
-              </a:defRPr>
-            </a:pPr>
-            <a:r>
-              <a:t>Dataset Overview</a:t>
-            </a:r>
+          <a:solidFill>
+            <a:srgbClr val="FAFAFC"/>
+          </a:solidFill>
+          <a:ln>
+            <a:solidFill>
+              <a:srgbClr val="FAFAFC"/>
+            </a:solidFill>
+          </a:ln>
+        </p:spPr>
+        <p:style>
+          <a:lnRef idx="1">
+            <a:schemeClr val="accent1"/>
+          </a:lnRef>
+          <a:fillRef idx="3">
+            <a:schemeClr val="accent1"/>
+          </a:fillRef>
+          <a:effectRef idx="2">
+            <a:schemeClr val="accent1"/>
+          </a:effectRef>
+          <a:fontRef idx="minor">
+            <a:schemeClr val="lt1"/>
+          </a:fontRef>
+        </p:style>
+        <p:txBody>
+          <a:bodyPr rtlCol="0" anchor="ctr"/>
+          <a:lstStyle/>
+          <a:p>
+            <a:pPr algn="ctr"/>
           </a:p>
         </p:txBody>
       </p:sp>
@@ -3517,8 +3706,8 @@
         </p:nvSpPr>
         <p:spPr>
           <a:xfrm>
-            <a:off x="457200" y="1097280"/>
-            <a:ext cx="8229600" cy="18288"/>
+            <a:off x="0" y="0"/>
+            <a:ext cx="9144000" cy="1005840"/>
           </a:xfrm>
           <a:prstGeom prst="rect">
             <a:avLst/>
@@ -3562,7 +3751,133 @@
         </p:nvSpPr>
         <p:spPr>
           <a:xfrm>
-            <a:off x="457200" y="1463040"/>
+            <a:off x="457200" y="228600"/>
+            <a:ext cx="8229600" cy="1097280"/>
+          </a:xfrm>
+          <a:prstGeom prst="rect">
+            <a:avLst/>
+          </a:prstGeom>
+          <a:noFill/>
+        </p:spPr>
+        <p:txBody>
+          <a:bodyPr wrap="none">
+            <a:spAutoFit/>
+          </a:bodyPr>
+          <a:lstStyle/>
+          <a:p>
+            <a:pPr algn="l">
+              <a:defRPr sz="4000" b="1">
+                <a:solidFill>
+                  <a:srgbClr val="FFFFFF"/>
+                </a:solidFill>
+                <a:latin typeface="Calibri"/>
+              </a:defRPr>
+            </a:pPr>
+            <a:r>
+              <a:t>Dataset Overview</a:t>
+            </a:r>
+          </a:p>
+        </p:txBody>
+      </p:sp>
+      <p:sp>
+        <p:nvSpPr>
+          <p:cNvPr id="5" name="Rectangle 4"/>
+          <p:cNvSpPr/>
+          <p:nvPr/>
+        </p:nvSpPr>
+        <p:spPr>
+          <a:xfrm>
+            <a:off x="457200" y="1051560"/>
+            <a:ext cx="8229600" cy="18288"/>
+          </a:xfrm>
+          <a:prstGeom prst="rect">
+            <a:avLst/>
+          </a:prstGeom>
+          <a:solidFill>
+            <a:srgbClr val="6366F1"/>
+          </a:solidFill>
+          <a:ln>
+            <a:solidFill>
+              <a:srgbClr val="6366F1"/>
+            </a:solidFill>
+          </a:ln>
+        </p:spPr>
+        <p:style>
+          <a:lnRef idx="1">
+            <a:schemeClr val="accent1"/>
+          </a:lnRef>
+          <a:fillRef idx="3">
+            <a:schemeClr val="accent1"/>
+          </a:fillRef>
+          <a:effectRef idx="2">
+            <a:schemeClr val="accent1"/>
+          </a:effectRef>
+          <a:fontRef idx="minor">
+            <a:schemeClr val="lt1"/>
+          </a:fontRef>
+        </p:style>
+        <p:txBody>
+          <a:bodyPr rtlCol="0" anchor="ctr"/>
+          <a:lstStyle/>
+          <a:p>
+            <a:pPr algn="ctr"/>
+          </a:p>
+        </p:txBody>
+      </p:sp>
+      <p:sp>
+        <p:nvSpPr>
+          <p:cNvPr id="6" name="Rectangle 5"/>
+          <p:cNvSpPr/>
+          <p:nvPr/>
+        </p:nvSpPr>
+        <p:spPr>
+          <a:xfrm>
+            <a:off x="457200" y="1280160"/>
+            <a:ext cx="8229600" cy="5120640"/>
+          </a:xfrm>
+          <a:prstGeom prst="rect">
+            <a:avLst/>
+          </a:prstGeom>
+          <a:solidFill>
+            <a:srgbClr val="FFFFFF"/>
+          </a:solidFill>
+          <a:ln w="25400">
+            <a:solidFill>
+              <a:srgbClr val="6366F1"/>
+            </a:solidFill>
+          </a:ln>
+        </p:spPr>
+        <p:style>
+          <a:lnRef idx="1">
+            <a:schemeClr val="accent1"/>
+          </a:lnRef>
+          <a:fillRef idx="3">
+            <a:schemeClr val="accent1"/>
+          </a:fillRef>
+          <a:effectRef idx="2">
+            <a:schemeClr val="accent1"/>
+          </a:effectRef>
+          <a:fontRef idx="minor">
+            <a:schemeClr val="lt1"/>
+          </a:fontRef>
+        </p:style>
+        <p:txBody>
+          <a:bodyPr rtlCol="0" anchor="ctr"/>
+          <a:lstStyle/>
+          <a:p>
+            <a:pPr algn="ctr"/>
+          </a:p>
+        </p:txBody>
+      </p:sp>
+      <p:sp>
+        <p:nvSpPr>
+          <p:cNvPr id="7" name="TextBox 6"/>
+          <p:cNvSpPr txBox="1"/>
+          <p:nvPr/>
+        </p:nvSpPr>
+        <p:spPr>
+          <a:xfrm>
+            <a:off x="457200" y="1554480"/>
             <a:ext cx="8229600" cy="4114800"/>
           </a:xfrm>
           <a:prstGeom prst="rect">
@@ -3588,7 +3903,7 @@
               </a:defRPr>
             </a:pPr>
             <a:r>
-              <a:t>Original dataset: 28 student records</a:t>
+              <a:t>▸  Original dataset: 28 student records</a:t>
             </a:r>
           </a:p>
           <a:p>
@@ -3604,7 +3919,7 @@
               </a:defRPr>
             </a:pPr>
             <a:r>
-              <a:t>Cleaned dataset: 21 valid rows (removed missing/invalid scores)</a:t>
+              <a:t>▸  Cleaned dataset: 21 valid rows (removed missing/invalid scores)</a:t>
             </a:r>
           </a:p>
           <a:p>
@@ -3620,7 +3935,7 @@
               </a:defRPr>
             </a:pPr>
             <a:r>
-              <a:t>Feature columns: Maths Advanced, Physics, Modern History</a:t>
+              <a:t>▸  Feature columns: Maths Advanced, Physics, Modern History</a:t>
             </a:r>
           </a:p>
           <a:p>
@@ -3636,7 +3951,7 @@
               </a:defRPr>
             </a:pPr>
             <a:r>
-              <a:t>Target column: Software Engineering Final Grade (0–100)</a:t>
+              <a:t>▸  Target column: Software Engineering Final Grade (0–100)</a:t>
             </a:r>
           </a:p>
           <a:p>
@@ -3652,7 +3967,7 @@
               </a:defRPr>
             </a:pPr>
             <a:r>
-              <a:t>Cleaning rules: drop NaN, enforce [0, 100] range per column</a:t>
+              <a:t>▸  Cleaning rules: drop NaN, enforce [0, 100] range per column</a:t>
             </a:r>
           </a:p>
         </p:txBody>
@@ -3677,37 +3992,46 @@
       <p:grpSpPr/>
       <p:sp>
         <p:nvSpPr>
-          <p:cNvPr id="2" name="TextBox 1"/>
-          <p:cNvSpPr txBox="1"/>
+          <p:cNvPr id="2" name="Rectangle 1"/>
+          <p:cNvSpPr/>
           <p:nvPr/>
         </p:nvSpPr>
         <p:spPr>
           <a:xfrm>
-            <a:off x="457200" y="457200"/>
-            <a:ext cx="8229600" cy="1097280"/>
+            <a:off x="0" y="0"/>
+            <a:ext cx="9144000" cy="6858000"/>
           </a:xfrm>
           <a:prstGeom prst="rect">
             <a:avLst/>
           </a:prstGeom>
-          <a:noFill/>
-        </p:spPr>
-        <p:txBody>
-          <a:bodyPr wrap="none">
-            <a:spAutoFit/>
-          </a:bodyPr>
-          <a:lstStyle/>
-          <a:p>
-            <a:pPr algn="l">
-              <a:defRPr sz="3800" b="1">
-                <a:solidFill>
-                  <a:srgbClr val="1E1E2E"/>
-                </a:solidFill>
-                <a:latin typeface="Calibri"/>
-              </a:defRPr>
-            </a:pPr>
-            <a:r>
-              <a:t>Model Strategy: Baseline vs. Level 2</a:t>
-            </a:r>
+          <a:solidFill>
+            <a:srgbClr val="FAFAFC"/>
+          </a:solidFill>
+          <a:ln>
+            <a:solidFill>
+              <a:srgbClr val="FAFAFC"/>
+            </a:solidFill>
+          </a:ln>
+        </p:spPr>
+        <p:style>
+          <a:lnRef idx="1">
+            <a:schemeClr val="accent1"/>
+          </a:lnRef>
+          <a:fillRef idx="3">
+            <a:schemeClr val="accent1"/>
+          </a:fillRef>
+          <a:effectRef idx="2">
+            <a:schemeClr val="accent1"/>
+          </a:effectRef>
+          <a:fontRef idx="minor">
+            <a:schemeClr val="lt1"/>
+          </a:fontRef>
+        </p:style>
+        <p:txBody>
+          <a:bodyPr rtlCol="0" anchor="ctr"/>
+          <a:lstStyle/>
+          <a:p>
+            <a:pPr algn="ctr"/>
           </a:p>
         </p:txBody>
       </p:sp>
@@ -3719,8 +4043,8 @@
         </p:nvSpPr>
         <p:spPr>
           <a:xfrm>
-            <a:off x="457200" y="1097280"/>
-            <a:ext cx="8229600" cy="18288"/>
+            <a:off x="0" y="0"/>
+            <a:ext cx="9144000" cy="1005840"/>
           </a:xfrm>
           <a:prstGeom prst="rect">
             <a:avLst/>
@@ -3764,8 +4088,8 @@
         </p:nvSpPr>
         <p:spPr>
           <a:xfrm>
-            <a:off x="457200" y="1463040"/>
-            <a:ext cx="3931920" cy="5029200"/>
+            <a:off x="457200" y="228600"/>
+            <a:ext cx="8229600" cy="1097280"/>
           </a:xfrm>
           <a:prstGeom prst="rect">
             <a:avLst/>
@@ -3773,83 +4097,125 @@
           <a:noFill/>
         </p:spPr>
         <p:txBody>
-          <a:bodyPr wrap="square">
+          <a:bodyPr wrap="none">
             <a:spAutoFit/>
           </a:bodyPr>
           <a:lstStyle/>
           <a:p>
-            <a:pPr>
-              <a:defRPr sz="1800" b="1">
-                <a:solidFill>
-                  <a:srgbClr val="6366F1"/>
+            <a:pPr algn="l">
+              <a:defRPr sz="3600" b="1">
+                <a:solidFill>
+                  <a:srgbClr val="FFFFFF"/>
                 </a:solidFill>
                 <a:latin typeface="Calibri"/>
               </a:defRPr>
             </a:pPr>
             <a:r>
-              <a:t>Baseline: Single-Feature</a:t>
-            </a:r>
-          </a:p>
-          <a:p>
-            <a:pPr>
-              <a:spcAft>
-                <a:spcPts val="600"/>
-              </a:spcAft>
-              <a:defRPr sz="1600">
-                <a:solidFill>
-                  <a:srgbClr val="1E1E2E"/>
-                </a:solidFill>
-                <a:latin typeface="Calibri"/>
-              </a:defRPr>
-            </a:pPr>
-            <a:r>
-              <a:t>Linear regression on Maths Advanced only</a:t>
-            </a:r>
-          </a:p>
-          <a:p>
-            <a:pPr>
-              <a:spcAft>
-                <a:spcPts val="600"/>
-              </a:spcAft>
-              <a:defRPr sz="1600">
-                <a:solidFill>
-                  <a:srgbClr val="1E1E2E"/>
-                </a:solidFill>
-                <a:latin typeface="Calibri"/>
-              </a:defRPr>
-            </a:pPr>
-            <a:r>
-              <a:t>Simple, interpretable</a:t>
-            </a:r>
-          </a:p>
-          <a:p>
-            <a:pPr>
-              <a:spcAft>
-                <a:spcPts val="600"/>
-              </a:spcAft>
-              <a:defRPr sz="1600">
-                <a:solidFill>
-                  <a:srgbClr val="1E1E2E"/>
-                </a:solidFill>
-                <a:latin typeface="Calibri"/>
-              </a:defRPr>
-            </a:pPr>
-            <a:r>
-              <a:t>Establishes performance baseline</a:t>
-            </a:r>
-          </a:p>
-        </p:txBody>
-      </p:sp>
-      <p:sp>
-        <p:nvSpPr>
-          <p:cNvPr id="5" name="TextBox 4"/>
+              <a:t>Model Strategy: Baseline vs. Level 2</a:t>
+            </a:r>
+          </a:p>
+        </p:txBody>
+      </p:sp>
+      <p:sp>
+        <p:nvSpPr>
+          <p:cNvPr id="5" name="Rectangle 4"/>
+          <p:cNvSpPr/>
+          <p:nvPr/>
+        </p:nvSpPr>
+        <p:spPr>
+          <a:xfrm>
+            <a:off x="457200" y="1051560"/>
+            <a:ext cx="8229600" cy="18288"/>
+          </a:xfrm>
+          <a:prstGeom prst="rect">
+            <a:avLst/>
+          </a:prstGeom>
+          <a:solidFill>
+            <a:srgbClr val="6366F1"/>
+          </a:solidFill>
+          <a:ln>
+            <a:solidFill>
+              <a:srgbClr val="6366F1"/>
+            </a:solidFill>
+          </a:ln>
+        </p:spPr>
+        <p:style>
+          <a:lnRef idx="1">
+            <a:schemeClr val="accent1"/>
+          </a:lnRef>
+          <a:fillRef idx="3">
+            <a:schemeClr val="accent1"/>
+          </a:fillRef>
+          <a:effectRef idx="2">
+            <a:schemeClr val="accent1"/>
+          </a:effectRef>
+          <a:fontRef idx="minor">
+            <a:schemeClr val="lt1"/>
+          </a:fontRef>
+        </p:style>
+        <p:txBody>
+          <a:bodyPr rtlCol="0" anchor="ctr"/>
+          <a:lstStyle/>
+          <a:p>
+            <a:pPr algn="ctr"/>
+          </a:p>
+        </p:txBody>
+      </p:sp>
+      <p:sp>
+        <p:nvSpPr>
+          <p:cNvPr id="6" name="Rectangle 5"/>
+          <p:cNvSpPr/>
+          <p:nvPr/>
+        </p:nvSpPr>
+        <p:spPr>
+          <a:xfrm>
+            <a:off x="457200" y="1280160"/>
+            <a:ext cx="3931920" cy="5120640"/>
+          </a:xfrm>
+          <a:prstGeom prst="rect">
+            <a:avLst/>
+          </a:prstGeom>
+          <a:solidFill>
+            <a:srgbClr val="F0F5FF"/>
+          </a:solidFill>
+          <a:ln w="25400">
+            <a:solidFill>
+              <a:srgbClr val="6366F1"/>
+            </a:solidFill>
+          </a:ln>
+        </p:spPr>
+        <p:style>
+          <a:lnRef idx="1">
+            <a:schemeClr val="accent1"/>
+          </a:lnRef>
+          <a:fillRef idx="3">
+            <a:schemeClr val="accent1"/>
+          </a:fillRef>
+          <a:effectRef idx="2">
+            <a:schemeClr val="accent1"/>
+          </a:effectRef>
+          <a:fontRef idx="minor">
+            <a:schemeClr val="lt1"/>
+          </a:fontRef>
+        </p:style>
+        <p:txBody>
+          <a:bodyPr rtlCol="0" anchor="ctr"/>
+          <a:lstStyle/>
+          <a:p>
+            <a:pPr algn="ctr"/>
+          </a:p>
+        </p:txBody>
+      </p:sp>
+      <p:sp>
+        <p:nvSpPr>
+          <p:cNvPr id="7" name="TextBox 6"/>
           <p:cNvSpPr txBox="1"/>
           <p:nvPr/>
         </p:nvSpPr>
         <p:spPr>
           <a:xfrm>
-            <a:off x="4754880" y="1463040"/>
-            <a:ext cx="3931920" cy="5029200"/>
+            <a:off x="640080" y="1463040"/>
+            <a:ext cx="3566160" cy="4754880"/>
           </a:xfrm>
           <a:prstGeom prst="rect">
             <a:avLst/>
@@ -3863,6 +4229,9 @@
           <a:lstStyle/>
           <a:p>
             <a:pPr>
+              <a:spcAft>
+                <a:spcPts val="1000"/>
+              </a:spcAft>
               <a:defRPr sz="1800" b="1">
                 <a:solidFill>
                   <a:srgbClr val="6366F1"/>
@@ -3871,15 +4240,15 @@
               </a:defRPr>
             </a:pPr>
             <a:r>
-              <a:t>Level 2: Multi-Feature</a:t>
+              <a:t>Baseline: Single-Feature</a:t>
             </a:r>
           </a:p>
           <a:p>
             <a:pPr>
               <a:spcAft>
-                <a:spcPts val="600"/>
+                <a:spcPts val="800"/>
               </a:spcAft>
-              <a:defRPr sz="1600">
+              <a:defRPr sz="1500">
                 <a:solidFill>
                   <a:srgbClr val="1E1E2E"/>
                 </a:solidFill>
@@ -3887,15 +4256,15 @@
               </a:defRPr>
             </a:pPr>
             <a:r>
-              <a:t>3 features + StandardScaler + LinearRegression</a:t>
+              <a:t>▸ Linear regression on Maths Advanced only</a:t>
             </a:r>
           </a:p>
           <a:p>
             <a:pPr>
               <a:spcAft>
-                <a:spcPts val="600"/>
+                <a:spcPts val="800"/>
               </a:spcAft>
-              <a:defRPr sz="1600">
+              <a:defRPr sz="1500">
                 <a:solidFill>
                   <a:srgbClr val="1E1E2E"/>
                 </a:solidFill>
@@ -3903,15 +4272,15 @@
               </a:defRPr>
             </a:pPr>
             <a:r>
-              <a:t>Reduces feature bias from different ranges</a:t>
+              <a:t>▸ Simple, interpretable</a:t>
             </a:r>
           </a:p>
           <a:p>
             <a:pPr>
               <a:spcAft>
-                <a:spcPts val="600"/>
+                <a:spcPts val="800"/>
               </a:spcAft>
-              <a:defRPr sz="1600">
+              <a:defRPr sz="1500">
                 <a:solidFill>
                   <a:srgbClr val="1E1E2E"/>
                 </a:solidFill>
@@ -3919,7 +4288,139 @@
               </a:defRPr>
             </a:pPr>
             <a:r>
-              <a:t>Better predictions with more context</a:t>
+              <a:t>▸ Establishes performance baseline</a:t>
+            </a:r>
+          </a:p>
+        </p:txBody>
+      </p:sp>
+      <p:sp>
+        <p:nvSpPr>
+          <p:cNvPr id="8" name="Rectangle 7"/>
+          <p:cNvSpPr/>
+          <p:nvPr/>
+        </p:nvSpPr>
+        <p:spPr>
+          <a:xfrm>
+            <a:off x="4754880" y="1280160"/>
+            <a:ext cx="3931920" cy="5120640"/>
+          </a:xfrm>
+          <a:prstGeom prst="rect">
+            <a:avLst/>
+          </a:prstGeom>
+          <a:solidFill>
+            <a:srgbClr val="F0FFF5"/>
+          </a:solidFill>
+          <a:ln w="25400">
+            <a:solidFill>
+              <a:srgbClr val="34D399"/>
+            </a:solidFill>
+          </a:ln>
+        </p:spPr>
+        <p:style>
+          <a:lnRef idx="1">
+            <a:schemeClr val="accent1"/>
+          </a:lnRef>
+          <a:fillRef idx="3">
+            <a:schemeClr val="accent1"/>
+          </a:fillRef>
+          <a:effectRef idx="2">
+            <a:schemeClr val="accent1"/>
+          </a:effectRef>
+          <a:fontRef idx="minor">
+            <a:schemeClr val="lt1"/>
+          </a:fontRef>
+        </p:style>
+        <p:txBody>
+          <a:bodyPr rtlCol="0" anchor="ctr"/>
+          <a:lstStyle/>
+          <a:p>
+            <a:pPr algn="ctr"/>
+          </a:p>
+        </p:txBody>
+      </p:sp>
+      <p:sp>
+        <p:nvSpPr>
+          <p:cNvPr id="9" name="TextBox 8"/>
+          <p:cNvSpPr txBox="1"/>
+          <p:nvPr/>
+        </p:nvSpPr>
+        <p:spPr>
+          <a:xfrm>
+            <a:off x="4937760" y="1463040"/>
+            <a:ext cx="3566160" cy="4754880"/>
+          </a:xfrm>
+          <a:prstGeom prst="rect">
+            <a:avLst/>
+          </a:prstGeom>
+          <a:noFill/>
+        </p:spPr>
+        <p:txBody>
+          <a:bodyPr wrap="square">
+            <a:spAutoFit/>
+          </a:bodyPr>
+          <a:lstStyle/>
+          <a:p>
+            <a:pPr>
+              <a:spcAft>
+                <a:spcPts val="1000"/>
+              </a:spcAft>
+              <a:defRPr sz="1800" b="1">
+                <a:solidFill>
+                  <a:srgbClr val="22C55E"/>
+                </a:solidFill>
+                <a:latin typeface="Calibri"/>
+              </a:defRPr>
+            </a:pPr>
+            <a:r>
+              <a:t>Level 2: Multi-Feature</a:t>
+            </a:r>
+          </a:p>
+          <a:p>
+            <a:pPr>
+              <a:spcAft>
+                <a:spcPts val="800"/>
+              </a:spcAft>
+              <a:defRPr sz="1500">
+                <a:solidFill>
+                  <a:srgbClr val="1E1E2E"/>
+                </a:solidFill>
+                <a:latin typeface="Calibri"/>
+              </a:defRPr>
+            </a:pPr>
+            <a:r>
+              <a:t>▸ 3 features + StandardScaler</a:t>
+            </a:r>
+          </a:p>
+          <a:p>
+            <a:pPr>
+              <a:spcAft>
+                <a:spcPts val="800"/>
+              </a:spcAft>
+              <a:defRPr sz="1500">
+                <a:solidFill>
+                  <a:srgbClr val="1E1E2E"/>
+                </a:solidFill>
+                <a:latin typeface="Calibri"/>
+              </a:defRPr>
+            </a:pPr>
+            <a:r>
+              <a:t>▸ Reduces feature bias</a:t>
+            </a:r>
+          </a:p>
+          <a:p>
+            <a:pPr>
+              <a:spcAft>
+                <a:spcPts val="800"/>
+              </a:spcAft>
+              <a:defRPr sz="1500">
+                <a:solidFill>
+                  <a:srgbClr val="1E1E2E"/>
+                </a:solidFill>
+                <a:latin typeface="Calibri"/>
+              </a:defRPr>
+            </a:pPr>
+            <a:r>
+              <a:t>▸ Better predictions with context</a:t>
             </a:r>
           </a:p>
         </p:txBody>
@@ -3944,37 +4445,46 @@
       <p:grpSpPr/>
       <p:sp>
         <p:nvSpPr>
-          <p:cNvPr id="2" name="TextBox 1"/>
-          <p:cNvSpPr txBox="1"/>
+          <p:cNvPr id="2" name="Rectangle 1"/>
+          <p:cNvSpPr/>
           <p:nvPr/>
         </p:nvSpPr>
         <p:spPr>
           <a:xfrm>
-            <a:off x="457200" y="457200"/>
-            <a:ext cx="8229600" cy="1097280"/>
+            <a:off x="0" y="0"/>
+            <a:ext cx="9144000" cy="6858000"/>
           </a:xfrm>
           <a:prstGeom prst="rect">
             <a:avLst/>
           </a:prstGeom>
-          <a:noFill/>
-        </p:spPr>
-        <p:txBody>
-          <a:bodyPr wrap="none">
-            <a:spAutoFit/>
-          </a:bodyPr>
-          <a:lstStyle/>
-          <a:p>
-            <a:pPr algn="l">
-              <a:defRPr sz="4000" b="1">
-                <a:solidFill>
-                  <a:srgbClr val="1E1E2E"/>
-                </a:solidFill>
-                <a:latin typeface="Calibri"/>
-              </a:defRPr>
-            </a:pPr>
-            <a:r>
-              <a:t>Validation &amp; Results</a:t>
-            </a:r>
+          <a:solidFill>
+            <a:srgbClr val="FAFAFC"/>
+          </a:solidFill>
+          <a:ln>
+            <a:solidFill>
+              <a:srgbClr val="FAFAFC"/>
+            </a:solidFill>
+          </a:ln>
+        </p:spPr>
+        <p:style>
+          <a:lnRef idx="1">
+            <a:schemeClr val="accent1"/>
+          </a:lnRef>
+          <a:fillRef idx="3">
+            <a:schemeClr val="accent1"/>
+          </a:fillRef>
+          <a:effectRef idx="2">
+            <a:schemeClr val="accent1"/>
+          </a:effectRef>
+          <a:fontRef idx="minor">
+            <a:schemeClr val="lt1"/>
+          </a:fontRef>
+        </p:style>
+        <p:txBody>
+          <a:bodyPr rtlCol="0" anchor="ctr"/>
+          <a:lstStyle/>
+          <a:p>
+            <a:pPr algn="ctr"/>
           </a:p>
         </p:txBody>
       </p:sp>
@@ -3986,8 +4496,8 @@
         </p:nvSpPr>
         <p:spPr>
           <a:xfrm>
-            <a:off x="457200" y="1097280"/>
-            <a:ext cx="8229600" cy="18288"/>
+            <a:off x="0" y="0"/>
+            <a:ext cx="9144000" cy="1005840"/>
           </a:xfrm>
           <a:prstGeom prst="rect">
             <a:avLst/>
@@ -4031,7 +4541,133 @@
         </p:nvSpPr>
         <p:spPr>
           <a:xfrm>
-            <a:off x="457200" y="1463040"/>
+            <a:off x="457200" y="228600"/>
+            <a:ext cx="8229600" cy="1097280"/>
+          </a:xfrm>
+          <a:prstGeom prst="rect">
+            <a:avLst/>
+          </a:prstGeom>
+          <a:noFill/>
+        </p:spPr>
+        <p:txBody>
+          <a:bodyPr wrap="none">
+            <a:spAutoFit/>
+          </a:bodyPr>
+          <a:lstStyle/>
+          <a:p>
+            <a:pPr algn="l">
+              <a:defRPr sz="4000" b="1">
+                <a:solidFill>
+                  <a:srgbClr val="FFFFFF"/>
+                </a:solidFill>
+                <a:latin typeface="Calibri"/>
+              </a:defRPr>
+            </a:pPr>
+            <a:r>
+              <a:t>Validation &amp; Results</a:t>
+            </a:r>
+          </a:p>
+        </p:txBody>
+      </p:sp>
+      <p:sp>
+        <p:nvSpPr>
+          <p:cNvPr id="5" name="Rectangle 4"/>
+          <p:cNvSpPr/>
+          <p:nvPr/>
+        </p:nvSpPr>
+        <p:spPr>
+          <a:xfrm>
+            <a:off x="457200" y="1051560"/>
+            <a:ext cx="8229600" cy="18288"/>
+          </a:xfrm>
+          <a:prstGeom prst="rect">
+            <a:avLst/>
+          </a:prstGeom>
+          <a:solidFill>
+            <a:srgbClr val="6366F1"/>
+          </a:solidFill>
+          <a:ln>
+            <a:solidFill>
+              <a:srgbClr val="6366F1"/>
+            </a:solidFill>
+          </a:ln>
+        </p:spPr>
+        <p:style>
+          <a:lnRef idx="1">
+            <a:schemeClr val="accent1"/>
+          </a:lnRef>
+          <a:fillRef idx="3">
+            <a:schemeClr val="accent1"/>
+          </a:fillRef>
+          <a:effectRef idx="2">
+            <a:schemeClr val="accent1"/>
+          </a:effectRef>
+          <a:fontRef idx="minor">
+            <a:schemeClr val="lt1"/>
+          </a:fontRef>
+        </p:style>
+        <p:txBody>
+          <a:bodyPr rtlCol="0" anchor="ctr"/>
+          <a:lstStyle/>
+          <a:p>
+            <a:pPr algn="ctr"/>
+          </a:p>
+        </p:txBody>
+      </p:sp>
+      <p:sp>
+        <p:nvSpPr>
+          <p:cNvPr id="6" name="Rectangle 5"/>
+          <p:cNvSpPr/>
+          <p:nvPr/>
+        </p:nvSpPr>
+        <p:spPr>
+          <a:xfrm>
+            <a:off x="457200" y="1280160"/>
+            <a:ext cx="8229600" cy="5120640"/>
+          </a:xfrm>
+          <a:prstGeom prst="rect">
+            <a:avLst/>
+          </a:prstGeom>
+          <a:solidFill>
+            <a:srgbClr val="FFFFFF"/>
+          </a:solidFill>
+          <a:ln w="25400">
+            <a:solidFill>
+              <a:srgbClr val="6366F1"/>
+            </a:solidFill>
+          </a:ln>
+        </p:spPr>
+        <p:style>
+          <a:lnRef idx="1">
+            <a:schemeClr val="accent1"/>
+          </a:lnRef>
+          <a:fillRef idx="3">
+            <a:schemeClr val="accent1"/>
+          </a:fillRef>
+          <a:effectRef idx="2">
+            <a:schemeClr val="accent1"/>
+          </a:effectRef>
+          <a:fontRef idx="minor">
+            <a:schemeClr val="lt1"/>
+          </a:fontRef>
+        </p:style>
+        <p:txBody>
+          <a:bodyPr rtlCol="0" anchor="ctr"/>
+          <a:lstStyle/>
+          <a:p>
+            <a:pPr algn="ctr"/>
+          </a:p>
+        </p:txBody>
+      </p:sp>
+      <p:sp>
+        <p:nvSpPr>
+          <p:cNvPr id="7" name="TextBox 6"/>
+          <p:cNvSpPr txBox="1"/>
+          <p:nvPr/>
+        </p:nvSpPr>
+        <p:spPr>
+          <a:xfrm>
+            <a:off x="457200" y="1554480"/>
             <a:ext cx="8229600" cy="4114800"/>
           </a:xfrm>
           <a:prstGeom prst="rect">
@@ -4057,7 +4693,7 @@
               </a:defRPr>
             </a:pPr>
             <a:r>
-              <a:t>Train-test split: 80% training, 20% testing (random_state=42)</a:t>
+              <a:t>▸  Train-test split: 80% training, 20% testing (random_state=42)</a:t>
             </a:r>
           </a:p>
           <a:p>
@@ -4073,7 +4709,7 @@
               </a:defRPr>
             </a:pPr>
             <a:r>
-              <a:t>Baseline RMSE: 4.49</a:t>
+              <a:t>▸  Baseline RMSE: 4.49</a:t>
             </a:r>
           </a:p>
           <a:p>
@@ -4089,7 +4725,7 @@
               </a:defRPr>
             </a:pPr>
             <a:r>
-              <a:t>Level 2 RMSE: 5.52</a:t>
+              <a:t>▸  Level 2 RMSE: 5.52</a:t>
             </a:r>
           </a:p>
           <a:p>
@@ -4105,7 +4741,7 @@
               </a:defRPr>
             </a:pPr>
             <a:r>
-              <a:t>Cross-validation RMSE (5-fold): 3.52</a:t>
+              <a:t>▸  Cross-validation RMSE (5-fold): 3.52</a:t>
             </a:r>
           </a:p>
           <a:p>
@@ -4121,7 +4757,7 @@
               </a:defRPr>
             </a:pPr>
             <a:r>
-              <a:t>Alex Anderson predicted final score: 86.1</a:t>
+              <a:t>▸  Alex Anderson predicted final score: 86.1</a:t>
             </a:r>
           </a:p>
         </p:txBody>
@@ -4146,37 +4782,46 @@
       <p:grpSpPr/>
       <p:sp>
         <p:nvSpPr>
-          <p:cNvPr id="2" name="TextBox 1"/>
-          <p:cNvSpPr txBox="1"/>
+          <p:cNvPr id="2" name="Rectangle 1"/>
+          <p:cNvSpPr/>
           <p:nvPr/>
         </p:nvSpPr>
         <p:spPr>
           <a:xfrm>
-            <a:off x="457200" y="457200"/>
-            <a:ext cx="8229600" cy="1097280"/>
+            <a:off x="0" y="0"/>
+            <a:ext cx="9144000" cy="6858000"/>
           </a:xfrm>
           <a:prstGeom prst="rect">
             <a:avLst/>
           </a:prstGeom>
-          <a:noFill/>
-        </p:spPr>
-        <p:txBody>
-          <a:bodyPr wrap="none">
-            <a:spAutoFit/>
-          </a:bodyPr>
-          <a:lstStyle/>
-          <a:p>
-            <a:pPr algn="l">
-              <a:defRPr sz="3800" b="1">
-                <a:solidFill>
-                  <a:srgbClr val="1E1E2E"/>
-                </a:solidFill>
-                <a:latin typeface="Calibri"/>
-              </a:defRPr>
-            </a:pPr>
-            <a:r>
-              <a:t>Bias Audit &amp; Ethical Safeguards</a:t>
-            </a:r>
+          <a:solidFill>
+            <a:srgbClr val="FAFAFC"/>
+          </a:solidFill>
+          <a:ln>
+            <a:solidFill>
+              <a:srgbClr val="FAFAFC"/>
+            </a:solidFill>
+          </a:ln>
+        </p:spPr>
+        <p:style>
+          <a:lnRef idx="1">
+            <a:schemeClr val="accent1"/>
+          </a:lnRef>
+          <a:fillRef idx="3">
+            <a:schemeClr val="accent1"/>
+          </a:fillRef>
+          <a:effectRef idx="2">
+            <a:schemeClr val="accent1"/>
+          </a:effectRef>
+          <a:fontRef idx="minor">
+            <a:schemeClr val="lt1"/>
+          </a:fontRef>
+        </p:style>
+        <p:txBody>
+          <a:bodyPr rtlCol="0" anchor="ctr"/>
+          <a:lstStyle/>
+          <a:p>
+            <a:pPr algn="ctr"/>
           </a:p>
         </p:txBody>
       </p:sp>
@@ -4188,8 +4833,8 @@
         </p:nvSpPr>
         <p:spPr>
           <a:xfrm>
-            <a:off x="457200" y="1097280"/>
-            <a:ext cx="8229600" cy="18288"/>
+            <a:off x="0" y="0"/>
+            <a:ext cx="9144000" cy="1005840"/>
           </a:xfrm>
           <a:prstGeom prst="rect">
             <a:avLst/>
@@ -4233,8 +4878,8 @@
         </p:nvSpPr>
         <p:spPr>
           <a:xfrm>
-            <a:off x="457200" y="1463040"/>
-            <a:ext cx="3931920" cy="5029200"/>
+            <a:off x="457200" y="228600"/>
+            <a:ext cx="8229600" cy="1097280"/>
           </a:xfrm>
           <a:prstGeom prst="rect">
             <a:avLst/>
@@ -4242,83 +4887,125 @@
           <a:noFill/>
         </p:spPr>
         <p:txBody>
-          <a:bodyPr wrap="square">
+          <a:bodyPr wrap="none">
             <a:spAutoFit/>
           </a:bodyPr>
           <a:lstStyle/>
           <a:p>
-            <a:pPr>
-              <a:defRPr sz="1800" b="1">
-                <a:solidFill>
-                  <a:srgbClr val="6366F1"/>
+            <a:pPr algn="l">
+              <a:defRPr sz="3600" b="1">
+                <a:solidFill>
+                  <a:srgbClr val="FFFFFF"/>
                 </a:solidFill>
                 <a:latin typeface="Calibri"/>
               </a:defRPr>
             </a:pPr>
             <a:r>
-              <a:t>Privacy &amp; Data Protection</a:t>
-            </a:r>
-          </a:p>
-          <a:p>
-            <a:pPr>
-              <a:spcAft>
-                <a:spcPts val="600"/>
-              </a:spcAft>
-              <a:defRPr sz="1600">
-                <a:solidFill>
-                  <a:srgbClr val="1E1E2E"/>
-                </a:solidFill>
-                <a:latin typeface="Calibri"/>
-              </a:defRPr>
-            </a:pPr>
-            <a:r>
-              <a:t>Anonymize student names</a:t>
-            </a:r>
-          </a:p>
-          <a:p>
-            <a:pPr>
-              <a:spcAft>
-                <a:spcPts val="600"/>
-              </a:spcAft>
-              <a:defRPr sz="1600">
-                <a:solidFill>
-                  <a:srgbClr val="1E1E2E"/>
-                </a:solidFill>
-                <a:latin typeface="Calibri"/>
-              </a:defRPr>
-            </a:pPr>
-            <a:r>
-              <a:t>Hash IDs for safe sharing</a:t>
-            </a:r>
-          </a:p>
-          <a:p>
-            <a:pPr>
-              <a:spcAft>
-                <a:spcPts val="600"/>
-              </a:spcAft>
-              <a:defRPr sz="1600">
-                <a:solidFill>
-                  <a:srgbClr val="1E1E2E"/>
-                </a:solidFill>
-                <a:latin typeface="Calibri"/>
-              </a:defRPr>
-            </a:pPr>
-            <a:r>
-              <a:t>Remove PII before export</a:t>
-            </a:r>
-          </a:p>
-        </p:txBody>
-      </p:sp>
-      <p:sp>
-        <p:nvSpPr>
-          <p:cNvPr id="5" name="TextBox 4"/>
+              <a:t>Bias Audit &amp; Ethical Safeguards</a:t>
+            </a:r>
+          </a:p>
+        </p:txBody>
+      </p:sp>
+      <p:sp>
+        <p:nvSpPr>
+          <p:cNvPr id="5" name="Rectangle 4"/>
+          <p:cNvSpPr/>
+          <p:nvPr/>
+        </p:nvSpPr>
+        <p:spPr>
+          <a:xfrm>
+            <a:off x="457200" y="1051560"/>
+            <a:ext cx="8229600" cy="18288"/>
+          </a:xfrm>
+          <a:prstGeom prst="rect">
+            <a:avLst/>
+          </a:prstGeom>
+          <a:solidFill>
+            <a:srgbClr val="6366F1"/>
+          </a:solidFill>
+          <a:ln>
+            <a:solidFill>
+              <a:srgbClr val="6366F1"/>
+            </a:solidFill>
+          </a:ln>
+        </p:spPr>
+        <p:style>
+          <a:lnRef idx="1">
+            <a:schemeClr val="accent1"/>
+          </a:lnRef>
+          <a:fillRef idx="3">
+            <a:schemeClr val="accent1"/>
+          </a:fillRef>
+          <a:effectRef idx="2">
+            <a:schemeClr val="accent1"/>
+          </a:effectRef>
+          <a:fontRef idx="minor">
+            <a:schemeClr val="lt1"/>
+          </a:fontRef>
+        </p:style>
+        <p:txBody>
+          <a:bodyPr rtlCol="0" anchor="ctr"/>
+          <a:lstStyle/>
+          <a:p>
+            <a:pPr algn="ctr"/>
+          </a:p>
+        </p:txBody>
+      </p:sp>
+      <p:sp>
+        <p:nvSpPr>
+          <p:cNvPr id="6" name="Rectangle 5"/>
+          <p:cNvSpPr/>
+          <p:nvPr/>
+        </p:nvSpPr>
+        <p:spPr>
+          <a:xfrm>
+            <a:off x="457200" y="1280160"/>
+            <a:ext cx="3931920" cy="5120640"/>
+          </a:xfrm>
+          <a:prstGeom prst="rect">
+            <a:avLst/>
+          </a:prstGeom>
+          <a:solidFill>
+            <a:srgbClr val="FFF5F0"/>
+          </a:solidFill>
+          <a:ln w="25400">
+            <a:solidFill>
+              <a:srgbClr val="F97316"/>
+            </a:solidFill>
+          </a:ln>
+        </p:spPr>
+        <p:style>
+          <a:lnRef idx="1">
+            <a:schemeClr val="accent1"/>
+          </a:lnRef>
+          <a:fillRef idx="3">
+            <a:schemeClr val="accent1"/>
+          </a:fillRef>
+          <a:effectRef idx="2">
+            <a:schemeClr val="accent1"/>
+          </a:effectRef>
+          <a:fontRef idx="minor">
+            <a:schemeClr val="lt1"/>
+          </a:fontRef>
+        </p:style>
+        <p:txBody>
+          <a:bodyPr rtlCol="0" anchor="ctr"/>
+          <a:lstStyle/>
+          <a:p>
+            <a:pPr algn="ctr"/>
+          </a:p>
+        </p:txBody>
+      </p:sp>
+      <p:sp>
+        <p:nvSpPr>
+          <p:cNvPr id="7" name="TextBox 6"/>
           <p:cNvSpPr txBox="1"/>
           <p:nvPr/>
         </p:nvSpPr>
         <p:spPr>
           <a:xfrm>
-            <a:off x="4754880" y="1463040"/>
-            <a:ext cx="3931920" cy="5029200"/>
+            <a:off x="640080" y="1463040"/>
+            <a:ext cx="3566160" cy="4754880"/>
           </a:xfrm>
           <a:prstGeom prst="rect">
             <a:avLst/>
@@ -4332,23 +5019,26 @@
           <a:lstStyle/>
           <a:p>
             <a:pPr>
+              <a:spcAft>
+                <a:spcPts val="1000"/>
+              </a:spcAft>
               <a:defRPr sz="1800" b="1">
                 <a:solidFill>
-                  <a:srgbClr val="6366F1"/>
+                  <a:srgbClr val="EA580C"/>
                 </a:solidFill>
                 <a:latin typeface="Calibri"/>
               </a:defRPr>
             </a:pPr>
             <a:r>
-              <a:t>Bias Detection</a:t>
+              <a:t>Privacy &amp; Data Protection</a:t>
             </a:r>
           </a:p>
           <a:p>
             <a:pPr>
               <a:spcAft>
-                <a:spcPts val="600"/>
+                <a:spcPts val="800"/>
               </a:spcAft>
-              <a:defRPr sz="1600">
+              <a:defRPr sz="1500">
                 <a:solidFill>
                   <a:srgbClr val="1E1E2E"/>
                 </a:solidFill>
@@ -4356,15 +5046,15 @@
               </a:defRPr>
             </a:pPr>
             <a:r>
-              <a:t>80% rule disparate impact check</a:t>
+              <a:t>▸ Anonymize student names</a:t>
             </a:r>
           </a:p>
           <a:p>
             <a:pPr>
               <a:spcAft>
-                <a:spcPts val="600"/>
+                <a:spcPts val="800"/>
               </a:spcAft>
-              <a:defRPr sz="1600">
+              <a:defRPr sz="1500">
                 <a:solidFill>
                   <a:srgbClr val="1E1E2E"/>
                 </a:solidFill>
@@ -4372,15 +5062,15 @@
               </a:defRPr>
             </a:pPr>
             <a:r>
-              <a:t>Compare subgroup pass rates</a:t>
+              <a:t>▸ Hash IDs for safe sharing</a:t>
             </a:r>
           </a:p>
           <a:p>
             <a:pPr>
               <a:spcAft>
-                <a:spcPts val="600"/>
+                <a:spcPts val="800"/>
               </a:spcAft>
-              <a:defRPr sz="1600">
+              <a:defRPr sz="1500">
                 <a:solidFill>
                   <a:srgbClr val="1E1E2E"/>
                 </a:solidFill>
@@ -4388,7 +5078,139 @@
               </a:defRPr>
             </a:pPr>
             <a:r>
-              <a:t>Audit report with warnings</a:t>
+              <a:t>▸ Remove PII before export</a:t>
+            </a:r>
+          </a:p>
+        </p:txBody>
+      </p:sp>
+      <p:sp>
+        <p:nvSpPr>
+          <p:cNvPr id="8" name="Rectangle 7"/>
+          <p:cNvSpPr/>
+          <p:nvPr/>
+        </p:nvSpPr>
+        <p:spPr>
+          <a:xfrm>
+            <a:off x="4754880" y="1280160"/>
+            <a:ext cx="3931920" cy="5120640"/>
+          </a:xfrm>
+          <a:prstGeom prst="rect">
+            <a:avLst/>
+          </a:prstGeom>
+          <a:solidFill>
+            <a:srgbClr val="F5FAFF"/>
+          </a:solidFill>
+          <a:ln w="25400">
+            <a:solidFill>
+              <a:srgbClr val="6366F1"/>
+            </a:solidFill>
+          </a:ln>
+        </p:spPr>
+        <p:style>
+          <a:lnRef idx="1">
+            <a:schemeClr val="accent1"/>
+          </a:lnRef>
+          <a:fillRef idx="3">
+            <a:schemeClr val="accent1"/>
+          </a:fillRef>
+          <a:effectRef idx="2">
+            <a:schemeClr val="accent1"/>
+          </a:effectRef>
+          <a:fontRef idx="minor">
+            <a:schemeClr val="lt1"/>
+          </a:fontRef>
+        </p:style>
+        <p:txBody>
+          <a:bodyPr rtlCol="0" anchor="ctr"/>
+          <a:lstStyle/>
+          <a:p>
+            <a:pPr algn="ctr"/>
+          </a:p>
+        </p:txBody>
+      </p:sp>
+      <p:sp>
+        <p:nvSpPr>
+          <p:cNvPr id="9" name="TextBox 8"/>
+          <p:cNvSpPr txBox="1"/>
+          <p:nvPr/>
+        </p:nvSpPr>
+        <p:spPr>
+          <a:xfrm>
+            <a:off x="4937760" y="1463040"/>
+            <a:ext cx="3566160" cy="4754880"/>
+          </a:xfrm>
+          <a:prstGeom prst="rect">
+            <a:avLst/>
+          </a:prstGeom>
+          <a:noFill/>
+        </p:spPr>
+        <p:txBody>
+          <a:bodyPr wrap="square">
+            <a:spAutoFit/>
+          </a:bodyPr>
+          <a:lstStyle/>
+          <a:p>
+            <a:pPr>
+              <a:spcAft>
+                <a:spcPts val="1000"/>
+              </a:spcAft>
+              <a:defRPr sz="1800" b="1">
+                <a:solidFill>
+                  <a:srgbClr val="6366F1"/>
+                </a:solidFill>
+                <a:latin typeface="Calibri"/>
+              </a:defRPr>
+            </a:pPr>
+            <a:r>
+              <a:t>Bias Detection &amp; Audit</a:t>
+            </a:r>
+          </a:p>
+          <a:p>
+            <a:pPr>
+              <a:spcAft>
+                <a:spcPts val="800"/>
+              </a:spcAft>
+              <a:defRPr sz="1500">
+                <a:solidFill>
+                  <a:srgbClr val="1E1E2E"/>
+                </a:solidFill>
+                <a:latin typeface="Calibri"/>
+              </a:defRPr>
+            </a:pPr>
+            <a:r>
+              <a:t>▸ 80% rule disparate impact</a:t>
+            </a:r>
+          </a:p>
+          <a:p>
+            <a:pPr>
+              <a:spcAft>
+                <a:spcPts val="800"/>
+              </a:spcAft>
+              <a:defRPr sz="1500">
+                <a:solidFill>
+                  <a:srgbClr val="1E1E2E"/>
+                </a:solidFill>
+                <a:latin typeface="Calibri"/>
+              </a:defRPr>
+            </a:pPr>
+            <a:r>
+              <a:t>▸ Subgroup pass rate analysis</a:t>
+            </a:r>
+          </a:p>
+          <a:p>
+            <a:pPr>
+              <a:spcAft>
+                <a:spcPts val="800"/>
+              </a:spcAft>
+              <a:defRPr sz="1500">
+                <a:solidFill>
+                  <a:srgbClr val="1E1E2E"/>
+                </a:solidFill>
+                <a:latin typeface="Calibri"/>
+              </a:defRPr>
+            </a:pPr>
+            <a:r>
+              <a:t>▸ Audit report with warnings</a:t>
             </a:r>
           </a:p>
         </p:txBody>
@@ -4413,37 +5235,46 @@
       <p:grpSpPr/>
       <p:sp>
         <p:nvSpPr>
-          <p:cNvPr id="2" name="TextBox 1"/>
-          <p:cNvSpPr txBox="1"/>
+          <p:cNvPr id="2" name="Rectangle 1"/>
+          <p:cNvSpPr/>
           <p:nvPr/>
         </p:nvSpPr>
         <p:spPr>
           <a:xfrm>
-            <a:off x="457200" y="457200"/>
-            <a:ext cx="8229600" cy="1097280"/>
+            <a:off x="0" y="0"/>
+            <a:ext cx="9144000" cy="6858000"/>
           </a:xfrm>
           <a:prstGeom prst="rect">
             <a:avLst/>
           </a:prstGeom>
-          <a:noFill/>
-        </p:spPr>
-        <p:txBody>
-          <a:bodyPr wrap="none">
-            <a:spAutoFit/>
-          </a:bodyPr>
-          <a:lstStyle/>
-          <a:p>
-            <a:pPr algn="l">
-              <a:defRPr sz="4000" b="1">
-                <a:solidFill>
-                  <a:srgbClr val="1E1E2E"/>
-                </a:solidFill>
-                <a:latin typeface="Calibri"/>
-              </a:defRPr>
-            </a:pPr>
-            <a:r>
-              <a:t>Submission-Ready Summary</a:t>
-            </a:r>
+          <a:solidFill>
+            <a:srgbClr val="FAFAFC"/>
+          </a:solidFill>
+          <a:ln>
+            <a:solidFill>
+              <a:srgbClr val="FAFAFC"/>
+            </a:solidFill>
+          </a:ln>
+        </p:spPr>
+        <p:style>
+          <a:lnRef idx="1">
+            <a:schemeClr val="accent1"/>
+          </a:lnRef>
+          <a:fillRef idx="3">
+            <a:schemeClr val="accent1"/>
+          </a:fillRef>
+          <a:effectRef idx="2">
+            <a:schemeClr val="accent1"/>
+          </a:effectRef>
+          <a:fontRef idx="minor">
+            <a:schemeClr val="lt1"/>
+          </a:fontRef>
+        </p:style>
+        <p:txBody>
+          <a:bodyPr rtlCol="0" anchor="ctr"/>
+          <a:lstStyle/>
+          <a:p>
+            <a:pPr algn="ctr"/>
           </a:p>
         </p:txBody>
       </p:sp>
@@ -4455,8 +5286,8 @@
         </p:nvSpPr>
         <p:spPr>
           <a:xfrm>
-            <a:off x="457200" y="1097280"/>
-            <a:ext cx="8229600" cy="18288"/>
+            <a:off x="0" y="0"/>
+            <a:ext cx="9144000" cy="1005840"/>
           </a:xfrm>
           <a:prstGeom prst="rect">
             <a:avLst/>
@@ -4500,8 +5331,8 @@
         </p:nvSpPr>
         <p:spPr>
           <a:xfrm>
-            <a:off x="457200" y="1463040"/>
-            <a:ext cx="8229600" cy="4114800"/>
+            <a:off x="457200" y="228600"/>
+            <a:ext cx="8229600" cy="1097280"/>
           </a:xfrm>
           <a:prstGeom prst="rect">
             <a:avLst/>
@@ -4509,6 +5340,132 @@
           <a:noFill/>
         </p:spPr>
         <p:txBody>
+          <a:bodyPr wrap="none">
+            <a:spAutoFit/>
+          </a:bodyPr>
+          <a:lstStyle/>
+          <a:p>
+            <a:pPr algn="l">
+              <a:defRPr sz="4000" b="1">
+                <a:solidFill>
+                  <a:srgbClr val="FFFFFF"/>
+                </a:solidFill>
+                <a:latin typeface="Calibri"/>
+              </a:defRPr>
+            </a:pPr>
+            <a:r>
+              <a:t>Submission-Ready Summary</a:t>
+            </a:r>
+          </a:p>
+        </p:txBody>
+      </p:sp>
+      <p:sp>
+        <p:nvSpPr>
+          <p:cNvPr id="5" name="Rectangle 4"/>
+          <p:cNvSpPr/>
+          <p:nvPr/>
+        </p:nvSpPr>
+        <p:spPr>
+          <a:xfrm>
+            <a:off x="457200" y="1051560"/>
+            <a:ext cx="8229600" cy="18288"/>
+          </a:xfrm>
+          <a:prstGeom prst="rect">
+            <a:avLst/>
+          </a:prstGeom>
+          <a:solidFill>
+            <a:srgbClr val="6366F1"/>
+          </a:solidFill>
+          <a:ln>
+            <a:solidFill>
+              <a:srgbClr val="6366F1"/>
+            </a:solidFill>
+          </a:ln>
+        </p:spPr>
+        <p:style>
+          <a:lnRef idx="1">
+            <a:schemeClr val="accent1"/>
+          </a:lnRef>
+          <a:fillRef idx="3">
+            <a:schemeClr val="accent1"/>
+          </a:fillRef>
+          <a:effectRef idx="2">
+            <a:schemeClr val="accent1"/>
+          </a:effectRef>
+          <a:fontRef idx="minor">
+            <a:schemeClr val="lt1"/>
+          </a:fontRef>
+        </p:style>
+        <p:txBody>
+          <a:bodyPr rtlCol="0" anchor="ctr"/>
+          <a:lstStyle/>
+          <a:p>
+            <a:pPr algn="ctr"/>
+          </a:p>
+        </p:txBody>
+      </p:sp>
+      <p:sp>
+        <p:nvSpPr>
+          <p:cNvPr id="6" name="Rectangle 5"/>
+          <p:cNvSpPr/>
+          <p:nvPr/>
+        </p:nvSpPr>
+        <p:spPr>
+          <a:xfrm>
+            <a:off x="457200" y="1280160"/>
+            <a:ext cx="8229600" cy="5120640"/>
+          </a:xfrm>
+          <a:prstGeom prst="rect">
+            <a:avLst/>
+          </a:prstGeom>
+          <a:solidFill>
+            <a:srgbClr val="FFFFFF"/>
+          </a:solidFill>
+          <a:ln w="25400">
+            <a:solidFill>
+              <a:srgbClr val="6366F1"/>
+            </a:solidFill>
+          </a:ln>
+        </p:spPr>
+        <p:style>
+          <a:lnRef idx="1">
+            <a:schemeClr val="accent1"/>
+          </a:lnRef>
+          <a:fillRef idx="3">
+            <a:schemeClr val="accent1"/>
+          </a:fillRef>
+          <a:effectRef idx="2">
+            <a:schemeClr val="accent1"/>
+          </a:effectRef>
+          <a:fontRef idx="minor">
+            <a:schemeClr val="lt1"/>
+          </a:fontRef>
+        </p:style>
+        <p:txBody>
+          <a:bodyPr rtlCol="0" anchor="ctr"/>
+          <a:lstStyle/>
+          <a:p>
+            <a:pPr algn="ctr"/>
+          </a:p>
+        </p:txBody>
+      </p:sp>
+      <p:sp>
+        <p:nvSpPr>
+          <p:cNvPr id="7" name="TextBox 6"/>
+          <p:cNvSpPr txBox="1"/>
+          <p:nvPr/>
+        </p:nvSpPr>
+        <p:spPr>
+          <a:xfrm>
+            <a:off x="457200" y="1554480"/>
+            <a:ext cx="8229600" cy="4114800"/>
+          </a:xfrm>
+          <a:prstGeom prst="rect">
+            <a:avLst/>
+          </a:prstGeom>
+          <a:noFill/>
+        </p:spPr>
+        <p:txBody>
           <a:bodyPr wrap="square">
             <a:spAutoFit/>
           </a:bodyPr>
@@ -4518,7 +5475,7 @@
               <a:spcAft>
                 <a:spcPts val="800"/>
               </a:spcAft>
-              <a:defRPr sz="1700">
+              <a:defRPr sz="1600">
                 <a:solidFill>
                   <a:srgbClr val="1E1E2E"/>
                 </a:solidFill>
@@ -4526,7 +5483,7 @@
               </a:defRPr>
             </a:pPr>
             <a:r>
-              <a:t>Software: Complete pipeline with data cleaning, training, evaluation, and ethics checks</a:t>
+              <a:t>▸  Software: Complete pipeline with data cleaning, training, evaluation, and ethics checks</a:t>
             </a:r>
           </a:p>
           <a:p>
@@ -4534,7 +5491,7 @@
               <a:spcAft>
                 <a:spcPts val="800"/>
               </a:spcAft>
-              <a:defRPr sz="1700">
+              <a:defRPr sz="1600">
                 <a:solidFill>
                   <a:srgbClr val="1E1E2E"/>
                 </a:solidFill>
@@ -4542,7 +5499,7 @@
               </a:defRPr>
             </a:pPr>
             <a:r>
-              <a:t>Results: Stable, reproducible RMSE metrics and student predictions</a:t>
+              <a:t>▸  Results: Stable, reproducible RMSE metrics and student predictions</a:t>
             </a:r>
           </a:p>
           <a:p>
@@ -4550,7 +5507,7 @@
               <a:spcAft>
                 <a:spcPts val="800"/>
               </a:spcAft>
-              <a:defRPr sz="1700">
+              <a:defRPr sz="1600">
                 <a:solidFill>
                   <a:srgbClr val="1E1E2E"/>
                 </a:solidFill>
@@ -4558,7 +5515,7 @@
               </a:defRPr>
             </a:pPr>
             <a:r>
-              <a:t>Documentation: Project writeup with all template sections filled</a:t>
+              <a:t>▸  Documentation: Project writeup with all template sections filled</a:t>
             </a:r>
           </a:p>
           <a:p>
@@ -4566,7 +5523,7 @@
               <a:spcAft>
                 <a:spcPts val="800"/>
               </a:spcAft>
-              <a:defRPr sz="1700">
+              <a:defRPr sz="1600">
                 <a:solidFill>
                   <a:srgbClr val="1E1E2E"/>
                 </a:solidFill>
@@ -4574,7 +5531,7 @@
               </a:defRPr>
             </a:pPr>
             <a:r>
-              <a:t>Testing: 13 passing unit tests with 61% code coverage</a:t>
+              <a:t>▸  Testing: 13 passing unit tests with 61% code coverage</a:t>
             </a:r>
           </a:p>
           <a:p>
@@ -4582,7 +5539,7 @@
               <a:spcAft>
                 <a:spcPts val="800"/>
               </a:spcAft>
-              <a:defRPr sz="1700">
+              <a:defRPr sz="1600">
                 <a:solidFill>
                   <a:srgbClr val="1E1E2E"/>
                 </a:solidFill>
@@ -4590,7 +5547,7 @@
               </a:defRPr>
             </a:pPr>
             <a:r>
-              <a:t>Code Quality: OOP design with AcademicPredictor class, anonymization, bias audit</a:t>
+              <a:t>▸  Code Quality: OOP design with AcademicPredictor class, anonymization, bias audit</a:t>
             </a:r>
           </a:p>
         </p:txBody>

</xml_diff>